<commit_message>
Add GBS waterfall chart and Mekko chart
- Chart 1 redesigned as proper GBS scope waterfall: floating gray bars
  show scope reductions (Process standardization -21, Strategic importance -21,
  System limitations -22) with stacked colored milestone columns
  using exact data from original McKinsey chart (193→129→95→34 FTE)
- Chart 6 (new): Mekko/Marimekko chart – Market Landscape by Region & Product Line
  Excel: 100% stacked column with market size annotations
  PowerPoint: true variable-width Mekko drawn with proportional rectangles

https://claude.ai/code/session_01Di57Cqdfup39DVN9Mc9hXr
</commit_message>
<xml_diff>
--- a/McKinsey_Slides.pptx
+++ b/McKinsey_Slides.pptx
@@ -10,6 +10,7 @@
     <p:sldId id="258" r:id="rId9"/>
     <p:sldId id="259" r:id="rId10"/>
     <p:sldId id="260" r:id="rId11"/>
+    <p:sldId id="261" r:id="rId12"/>
   </p:sldIdLst>
   <p:sldSz cx="12188952" cy="6858000" type="screen4x3"/>
   <p:notesSz cx="6858000" cy="9144000"/>
@@ -118,7 +119,7 @@
     <c:autoTitleDeleted val="1"/>
     <c:plotArea>
       <c:barChart>
-        <c:barDir val="bar"/>
+        <c:barDir val="col"/>
         <c:grouping val="stacked"/>
         <c:ser>
           <c:idx val="0"/>
@@ -129,7 +130,319 @@
               <c:strCache>
                 <c:ptCount val="1"/>
                 <c:pt idx="0">
-                  <c:v>Sales Support</c:v>
+                  <c:v>Spacer</c:v>
+                </c:pt>
+              </c:strCache>
+            </c:strRef>
+          </c:tx>
+          <c:spPr>
+            <a:noFill/>
+            <a:ln>
+              <a:noFill/>
+            </a:ln>
+          </c:spPr>
+          <c:cat>
+            <c:strRef>
+              <c:f>Sheet1!$A$2:$A$8</c:f>
+              <c:strCache>
+                <c:ptCount val="7"/>
+                <c:pt idx="0">
+                  <c:v>Benchmark
+scope</c:v>
+                </c:pt>
+                <c:pt idx="1">
+                  <c:v>Process
+standardization</c:v>
+                </c:pt>
+                <c:pt idx="2">
+                  <c:v>Strategic
+importance</c:v>
+                </c:pt>
+                <c:pt idx="3">
+                  <c:v>System
+limitations</c:v>
+                </c:pt>
+                <c:pt idx="4">
+                  <c:v>Signed-off
+scope</c:v>
+                </c:pt>
+                <c:pt idx="5">
+                  <c:v>Transferred
+to date</c:v>
+                </c:pt>
+                <c:pt idx="6">
+                  <c:v>To be
+transferred</c:v>
+                </c:pt>
+              </c:strCache>
+            </c:strRef>
+          </c:cat>
+          <c:val>
+            <c:numRef>
+              <c:f>Sheet1!$B$2:$B$8</c:f>
+              <c:numCache>
+                <c:formatCode>General</c:formatCode>
+                <c:ptCount val="7"/>
+                <c:pt idx="0">
+                  <c:v>0</c:v>
+                </c:pt>
+                <c:pt idx="1">
+                  <c:v>172</c:v>
+                </c:pt>
+                <c:pt idx="2">
+                  <c:v>151</c:v>
+                </c:pt>
+                <c:pt idx="3">
+                  <c:v>129</c:v>
+                </c:pt>
+                <c:pt idx="4">
+                  <c:v>0</c:v>
+                </c:pt>
+                <c:pt idx="5">
+                  <c:v>0</c:v>
+                </c:pt>
+                <c:pt idx="6">
+                  <c:v>0</c:v>
+                </c:pt>
+              </c:numCache>
+            </c:numRef>
+          </c:val>
+        </c:ser>
+        <c:ser>
+          <c:idx val="1"/>
+          <c:order val="1"/>
+          <c:tx>
+            <c:strRef>
+              <c:f>Sheet1!$C$1</c:f>
+              <c:strCache>
+                <c:ptCount val="1"/>
+                <c:pt idx="0">
+                  <c:v>Scope reduction</c:v>
+                </c:pt>
+              </c:strCache>
+            </c:strRef>
+          </c:tx>
+          <c:spPr>
+            <a:solidFill>
+              <a:srgbClr val="D9D9D9"/>
+            </a:solidFill>
+            <a:ln>
+              <a:solidFill>
+                <a:srgbClr val="D9D9D9"/>
+              </a:solidFill>
+            </a:ln>
+          </c:spPr>
+          <c:dLbls>
+            <c:txPr>
+              <a:bodyPr/>
+              <a:lstStyle/>
+              <a:p>
+                <a:pPr>
+                  <a:defRPr sz="900" b="1">
+                    <a:latin typeface="Arial"/>
+                  </a:defRPr>
+                </a:pPr>
+              </a:p>
+            </c:txPr>
+            <c:showLegendKey val="0"/>
+            <c:showVal val="1"/>
+            <c:showCatName val="0"/>
+            <c:showSerName val="0"/>
+            <c:showPercent val="0"/>
+            <c:showBubbleSize val="0"/>
+            <c:showLeaderLines val="1"/>
+          </c:dLbls>
+          <c:cat>
+            <c:strRef>
+              <c:f>Sheet1!$A$2:$A$8</c:f>
+              <c:strCache>
+                <c:ptCount val="7"/>
+                <c:pt idx="0">
+                  <c:v>Benchmark
+scope</c:v>
+                </c:pt>
+                <c:pt idx="1">
+                  <c:v>Process
+standardization</c:v>
+                </c:pt>
+                <c:pt idx="2">
+                  <c:v>Strategic
+importance</c:v>
+                </c:pt>
+                <c:pt idx="3">
+                  <c:v>System
+limitations</c:v>
+                </c:pt>
+                <c:pt idx="4">
+                  <c:v>Signed-off
+scope</c:v>
+                </c:pt>
+                <c:pt idx="5">
+                  <c:v>Transferred
+to date</c:v>
+                </c:pt>
+                <c:pt idx="6">
+                  <c:v>To be
+transferred</c:v>
+                </c:pt>
+              </c:strCache>
+            </c:strRef>
+          </c:cat>
+          <c:val>
+            <c:numRef>
+              <c:f>Sheet1!$C$2:$C$8</c:f>
+              <c:numCache>
+                <c:formatCode>General</c:formatCode>
+                <c:ptCount val="7"/>
+                <c:pt idx="0">
+                  <c:v>0</c:v>
+                </c:pt>
+                <c:pt idx="1">
+                  <c:v>21</c:v>
+                </c:pt>
+                <c:pt idx="2">
+                  <c:v>21</c:v>
+                </c:pt>
+                <c:pt idx="3">
+                  <c:v>22</c:v>
+                </c:pt>
+                <c:pt idx="4">
+                  <c:v>0</c:v>
+                </c:pt>
+                <c:pt idx="5">
+                  <c:v>0</c:v>
+                </c:pt>
+                <c:pt idx="6">
+                  <c:v>0</c:v>
+                </c:pt>
+              </c:numCache>
+            </c:numRef>
+          </c:val>
+        </c:ser>
+        <c:ser>
+          <c:idx val="2"/>
+          <c:order val="2"/>
+          <c:tx>
+            <c:strRef>
+              <c:f>Sheet1!$D$1</c:f>
+              <c:strCache>
+                <c:ptCount val="1"/>
+                <c:pt idx="0">
+                  <c:v>Accounting</c:v>
+                </c:pt>
+              </c:strCache>
+            </c:strRef>
+          </c:tx>
+          <c:spPr>
+            <a:solidFill>
+              <a:srgbClr val="000000"/>
+            </a:solidFill>
+            <a:ln>
+              <a:solidFill>
+                <a:srgbClr val="000000"/>
+              </a:solidFill>
+            </a:ln>
+          </c:spPr>
+          <c:dLbls>
+            <c:txPr>
+              <a:bodyPr/>
+              <a:lstStyle/>
+              <a:p>
+                <a:pPr>
+                  <a:defRPr sz="900" b="1">
+                    <a:solidFill>
+                      <a:srgbClr val="FFFFFF"/>
+                    </a:solidFill>
+                    <a:latin typeface="Arial"/>
+                  </a:defRPr>
+                </a:pPr>
+              </a:p>
+            </c:txPr>
+            <c:showLegendKey val="0"/>
+            <c:showVal val="1"/>
+            <c:showCatName val="0"/>
+            <c:showSerName val="0"/>
+            <c:showPercent val="0"/>
+            <c:showBubbleSize val="0"/>
+            <c:showLeaderLines val="1"/>
+          </c:dLbls>
+          <c:cat>
+            <c:strRef>
+              <c:f>Sheet1!$A$2:$A$8</c:f>
+              <c:strCache>
+                <c:ptCount val="7"/>
+                <c:pt idx="0">
+                  <c:v>Benchmark
+scope</c:v>
+                </c:pt>
+                <c:pt idx="1">
+                  <c:v>Process
+standardization</c:v>
+                </c:pt>
+                <c:pt idx="2">
+                  <c:v>Strategic
+importance</c:v>
+                </c:pt>
+                <c:pt idx="3">
+                  <c:v>System
+limitations</c:v>
+                </c:pt>
+                <c:pt idx="4">
+                  <c:v>Signed-off
+scope</c:v>
+                </c:pt>
+                <c:pt idx="5">
+                  <c:v>Transferred
+to date</c:v>
+                </c:pt>
+                <c:pt idx="6">
+                  <c:v>To be
+transferred</c:v>
+                </c:pt>
+              </c:strCache>
+            </c:strRef>
+          </c:cat>
+          <c:val>
+            <c:numRef>
+              <c:f>Sheet1!$D$2:$D$8</c:f>
+              <c:numCache>
+                <c:formatCode>General</c:formatCode>
+                <c:ptCount val="7"/>
+                <c:pt idx="0">
+                  <c:v>89</c:v>
+                </c:pt>
+                <c:pt idx="1">
+                  <c:v>0</c:v>
+                </c:pt>
+                <c:pt idx="2">
+                  <c:v>0</c:v>
+                </c:pt>
+                <c:pt idx="3">
+                  <c:v>0</c:v>
+                </c:pt>
+                <c:pt idx="4">
+                  <c:v>66</c:v>
+                </c:pt>
+                <c:pt idx="5">
+                  <c:v>45</c:v>
+                </c:pt>
+                <c:pt idx="6">
+                  <c:v>21</c:v>
+                </c:pt>
+              </c:numCache>
+            </c:numRef>
+          </c:val>
+        </c:ser>
+        <c:ser>
+          <c:idx val="3"/>
+          <c:order val="3"/>
+          <c:tx>
+            <c:strRef>
+              <c:f>Sheet1!$E$1</c:f>
+              <c:strCache>
+                <c:ptCount val="1"/>
+                <c:pt idx="0">
+                  <c:v>Customer Service</c:v>
                 </c:pt>
               </c:strCache>
             </c:strRef>
@@ -150,7 +463,10 @@
               <a:lstStyle/>
               <a:p>
                 <a:pPr>
-                  <a:defRPr sz="800">
+                  <a:defRPr sz="900" b="1">
+                    <a:solidFill>
+                      <a:srgbClr val="FFFFFF"/>
+                    </a:solidFill>
                     <a:latin typeface="Arial"/>
                   </a:defRPr>
                 </a:pPr>
@@ -170,66 +486,73 @@
               <c:strCache>
                 <c:ptCount val="7"/>
                 <c:pt idx="0">
-                  <c:v>Benchmark scope</c:v>
+                  <c:v>Benchmark
+scope</c:v>
                 </c:pt>
                 <c:pt idx="1">
-                  <c:v>Process standardization</c:v>
+                  <c:v>Process
+standardization</c:v>
                 </c:pt>
                 <c:pt idx="2">
-                  <c:v>Strategic importance</c:v>
+                  <c:v>Strategic
+importance</c:v>
                 </c:pt>
                 <c:pt idx="3">
-                  <c:v>System limitations</c:v>
+                  <c:v>System
+limitations</c:v>
                 </c:pt>
                 <c:pt idx="4">
-                  <c:v>Signed-off scope</c:v>
+                  <c:v>Signed-off
+scope</c:v>
                 </c:pt>
                 <c:pt idx="5">
-                  <c:v>Transferred to date</c:v>
+                  <c:v>Transferred
+to date</c:v>
                 </c:pt>
                 <c:pt idx="6">
-                  <c:v>To be transferred</c:v>
+                  <c:v>To be
+transferred</c:v>
                 </c:pt>
               </c:strCache>
             </c:strRef>
           </c:cat>
           <c:val>
             <c:numRef>
-              <c:f>Sheet1!$B$2:$B$8</c:f>
+              <c:f>Sheet1!$E$2:$E$8</c:f>
               <c:numCache>
                 <c:formatCode>General</c:formatCode>
                 <c:ptCount val="7"/>
                 <c:pt idx="0">
-                  <c:v>450</c:v>
+                  <c:v>45</c:v>
                 </c:pt>
                 <c:pt idx="1">
-                  <c:v>380</c:v>
+                  <c:v>0</c:v>
                 </c:pt>
                 <c:pt idx="2">
-                  <c:v>320</c:v>
+                  <c:v>0</c:v>
                 </c:pt>
                 <c:pt idx="3">
-                  <c:v>280</c:v>
+                  <c:v>0</c:v>
                 </c:pt>
                 <c:pt idx="4">
-                  <c:v>250</c:v>
+                  <c:v>31</c:v>
                 </c:pt>
                 <c:pt idx="5">
-                  <c:v>180</c:v>
+                  <c:v>23</c:v>
                 </c:pt>
                 <c:pt idx="6">
-                  <c:v>120</c:v>
+                  <c:v>8</c:v>
                 </c:pt>
               </c:numCache>
             </c:numRef>
           </c:val>
         </c:ser>
         <c:ser>
-          <c:idx val="1"/>
-          <c:order val="1"/>
+          <c:idx val="4"/>
+          <c:order val="4"/>
           <c:tx>
             <c:strRef>
-              <c:f>Sheet1!$C$1</c:f>
+              <c:f>Sheet1!$F$1</c:f>
               <c:strCache>
                 <c:ptCount val="1"/>
                 <c:pt idx="0">
@@ -254,7 +577,10 @@
               <a:lstStyle/>
               <a:p>
                 <a:pPr>
-                  <a:defRPr sz="800">
+                  <a:defRPr sz="900" b="1">
+                    <a:solidFill>
+                      <a:srgbClr val="FFFFFF"/>
+                    </a:solidFill>
                     <a:latin typeface="Arial"/>
                   </a:defRPr>
                 </a:pPr>
@@ -274,70 +600,77 @@
               <c:strCache>
                 <c:ptCount val="7"/>
                 <c:pt idx="0">
-                  <c:v>Benchmark scope</c:v>
+                  <c:v>Benchmark
+scope</c:v>
                 </c:pt>
                 <c:pt idx="1">
-                  <c:v>Process standardization</c:v>
+                  <c:v>Process
+standardization</c:v>
                 </c:pt>
                 <c:pt idx="2">
-                  <c:v>Strategic importance</c:v>
+                  <c:v>Strategic
+importance</c:v>
                 </c:pt>
                 <c:pt idx="3">
-                  <c:v>System limitations</c:v>
+                  <c:v>System
+limitations</c:v>
                 </c:pt>
                 <c:pt idx="4">
-                  <c:v>Signed-off scope</c:v>
+                  <c:v>Signed-off
+scope</c:v>
                 </c:pt>
                 <c:pt idx="5">
-                  <c:v>Transferred to date</c:v>
+                  <c:v>Transferred
+to date</c:v>
                 </c:pt>
                 <c:pt idx="6">
-                  <c:v>To be transferred</c:v>
+                  <c:v>To be
+transferred</c:v>
                 </c:pt>
               </c:strCache>
             </c:strRef>
           </c:cat>
           <c:val>
             <c:numRef>
-              <c:f>Sheet1!$C$2:$C$8</c:f>
+              <c:f>Sheet1!$F$2:$F$8</c:f>
               <c:numCache>
                 <c:formatCode>General</c:formatCode>
                 <c:ptCount val="7"/>
                 <c:pt idx="0">
-                  <c:v>120</c:v>
+                  <c:v>34</c:v>
                 </c:pt>
                 <c:pt idx="1">
-                  <c:v>90</c:v>
+                  <c:v>0</c:v>
                 </c:pt>
                 <c:pt idx="2">
-                  <c:v>80</c:v>
+                  <c:v>0</c:v>
                 </c:pt>
                 <c:pt idx="3">
-                  <c:v>70</c:v>
+                  <c:v>0</c:v>
                 </c:pt>
                 <c:pt idx="4">
-                  <c:v>60</c:v>
+                  <c:v>19</c:v>
                 </c:pt>
                 <c:pt idx="5">
-                  <c:v>45</c:v>
+                  <c:v>19</c:v>
                 </c:pt>
                 <c:pt idx="6">
-                  <c:v>30</c:v>
+                  <c:v>5</c:v>
                 </c:pt>
               </c:numCache>
             </c:numRef>
           </c:val>
         </c:ser>
         <c:ser>
-          <c:idx val="2"/>
-          <c:order val="2"/>
+          <c:idx val="5"/>
+          <c:order val="5"/>
           <c:tx>
             <c:strRef>
-              <c:f>Sheet1!$D$1</c:f>
+              <c:f>Sheet1!$G$1</c:f>
               <c:strCache>
                 <c:ptCount val="1"/>
                 <c:pt idx="0">
-                  <c:v>Customer Service</c:v>
+                  <c:v>Sales Support</c:v>
                 </c:pt>
               </c:strCache>
             </c:strRef>
@@ -358,7 +691,10 @@
               <a:lstStyle/>
               <a:p>
                 <a:pPr>
-                  <a:defRPr sz="800">
+                  <a:defRPr sz="900" b="1">
+                    <a:solidFill>
+                      <a:srgbClr val="000000"/>
+                    </a:solidFill>
                     <a:latin typeface="Arial"/>
                   </a:defRPr>
                 </a:pPr>
@@ -378,159 +714,62 @@
               <c:strCache>
                 <c:ptCount val="7"/>
                 <c:pt idx="0">
-                  <c:v>Benchmark scope</c:v>
+                  <c:v>Benchmark
+scope</c:v>
                 </c:pt>
                 <c:pt idx="1">
-                  <c:v>Process standardization</c:v>
+                  <c:v>Process
+standardization</c:v>
                 </c:pt>
                 <c:pt idx="2">
-                  <c:v>Strategic importance</c:v>
+                  <c:v>Strategic
+importance</c:v>
                 </c:pt>
                 <c:pt idx="3">
-                  <c:v>System limitations</c:v>
+                  <c:v>System
+limitations</c:v>
                 </c:pt>
                 <c:pt idx="4">
-                  <c:v>Signed-off scope</c:v>
+                  <c:v>Signed-off
+scope</c:v>
                 </c:pt>
                 <c:pt idx="5">
-                  <c:v>Transferred to date</c:v>
+                  <c:v>Transferred
+to date</c:v>
                 </c:pt>
                 <c:pt idx="6">
-                  <c:v>To be transferred</c:v>
+                  <c:v>To be
+transferred</c:v>
                 </c:pt>
               </c:strCache>
             </c:strRef>
           </c:cat>
           <c:val>
             <c:numRef>
-              <c:f>Sheet1!$D$2:$D$8</c:f>
+              <c:f>Sheet1!$G$2:$G$8</c:f>
               <c:numCache>
                 <c:formatCode>General</c:formatCode>
                 <c:ptCount val="7"/>
                 <c:pt idx="0">
-                  <c:v>180</c:v>
+                  <c:v>25</c:v>
                 </c:pt>
                 <c:pt idx="1">
-                  <c:v>150</c:v>
+                  <c:v>0</c:v>
                 </c:pt>
                 <c:pt idx="2">
-                  <c:v>130</c:v>
+                  <c:v>0</c:v>
                 </c:pt>
                 <c:pt idx="3">
-                  <c:v>110</c:v>
+                  <c:v>0</c:v>
                 </c:pt>
                 <c:pt idx="4">
-                  <c:v>100</c:v>
+                  <c:v>13</c:v>
                 </c:pt>
                 <c:pt idx="5">
-                  <c:v>70</c:v>
+                  <c:v>8</c:v>
                 </c:pt>
                 <c:pt idx="6">
-                  <c:v>45</c:v>
-                </c:pt>
-              </c:numCache>
-            </c:numRef>
-          </c:val>
-        </c:ser>
-        <c:ser>
-          <c:idx val="3"/>
-          <c:order val="3"/>
-          <c:tx>
-            <c:strRef>
-              <c:f>Sheet1!$E$1</c:f>
-              <c:strCache>
-                <c:ptCount val="1"/>
-                <c:pt idx="0">
-                  <c:v>Accounting</c:v>
-                </c:pt>
-              </c:strCache>
-            </c:strRef>
-          </c:tx>
-          <c:spPr>
-            <a:solidFill>
-              <a:srgbClr val="D9D9D9"/>
-            </a:solidFill>
-            <a:ln>
-              <a:solidFill>
-                <a:srgbClr val="D9D9D9"/>
-              </a:solidFill>
-            </a:ln>
-          </c:spPr>
-          <c:dLbls>
-            <c:txPr>
-              <a:bodyPr/>
-              <a:lstStyle/>
-              <a:p>
-                <a:pPr>
-                  <a:defRPr sz="800">
-                    <a:latin typeface="Arial"/>
-                  </a:defRPr>
-                </a:pPr>
-              </a:p>
-            </c:txPr>
-            <c:showLegendKey val="0"/>
-            <c:showVal val="1"/>
-            <c:showCatName val="0"/>
-            <c:showSerName val="0"/>
-            <c:showPercent val="0"/>
-            <c:showBubbleSize val="0"/>
-            <c:showLeaderLines val="1"/>
-          </c:dLbls>
-          <c:cat>
-            <c:strRef>
-              <c:f>Sheet1!$A$2:$A$8</c:f>
-              <c:strCache>
-                <c:ptCount val="7"/>
-                <c:pt idx="0">
-                  <c:v>Benchmark scope</c:v>
-                </c:pt>
-                <c:pt idx="1">
-                  <c:v>Process standardization</c:v>
-                </c:pt>
-                <c:pt idx="2">
-                  <c:v>Strategic importance</c:v>
-                </c:pt>
-                <c:pt idx="3">
-                  <c:v>System limitations</c:v>
-                </c:pt>
-                <c:pt idx="4">
-                  <c:v>Signed-off scope</c:v>
-                </c:pt>
-                <c:pt idx="5">
-                  <c:v>Transferred to date</c:v>
-                </c:pt>
-                <c:pt idx="6">
-                  <c:v>To be transferred</c:v>
-                </c:pt>
-              </c:strCache>
-            </c:strRef>
-          </c:cat>
-          <c:val>
-            <c:numRef>
-              <c:f>Sheet1!$E$2:$E$8</c:f>
-              <c:numCache>
-                <c:formatCode>General</c:formatCode>
-                <c:ptCount val="7"/>
-                <c:pt idx="0">
-                  <c:v>250</c:v>
-                </c:pt>
-                <c:pt idx="1">
-                  <c:v>200</c:v>
-                </c:pt>
-                <c:pt idx="2">
-                  <c:v>170</c:v>
-                </c:pt>
-                <c:pt idx="3">
-                  <c:v>150</c:v>
-                </c:pt>
-                <c:pt idx="4">
-                  <c:v>130</c:v>
-                </c:pt>
-                <c:pt idx="5">
-                  <c:v>90</c:v>
-                </c:pt>
-                <c:pt idx="6">
-                  <c:v>60</c:v>
+                  <c:v>0</c:v>
                 </c:pt>
               </c:numCache>
             </c:numRef>
@@ -546,7 +785,7 @@
           <c:orientation val="minMax"/>
         </c:scaling>
         <c:delete val="0"/>
-        <c:axPos val="l"/>
+        <c:axPos val="b"/>
         <c:majorTickMark val="out"/>
         <c:minorTickMark val="none"/>
         <c:tickLblPos val="nextTo"/>
@@ -561,7 +800,7 @@
         <c:axId val="-2113994440"/>
         <c:scaling/>
         <c:delete val="0"/>
-        <c:axPos val="b"/>
+        <c:axPos val="l"/>
         <c:majorGridlines/>
         <c:majorTickMark val="out"/>
         <c:minorTickMark val="none"/>
@@ -5511,7 +5750,7 @@
               </a:defRPr>
             </a:pPr>
             <a:r>
-              <a:t>~FTE involved in scope definition process</a:t>
+              <a:t>FTE</a:t>
             </a:r>
           </a:p>
         </p:txBody>
@@ -6794,6 +7033,1751 @@
             </a:pPr>
             <a:r>
               <a:t>Source: Logistics Operations Data 2024</a:t>
+            </a:r>
+          </a:p>
+        </p:txBody>
+      </p:sp>
+    </p:spTree>
+  </p:cSld>
+  <p:clrMapOvr>
+    <a:masterClrMapping/>
+  </p:clrMapOvr>
+</p:sld>
+</file>
+
+<file path=ppt/slides/slide6.xml><?xml version="1.0" encoding="utf-8"?>
+<p:sld xmlns:a="http://schemas.openxmlformats.org/drawingml/2006/main" xmlns:p="http://schemas.openxmlformats.org/presentationml/2006/main" xmlns:r="http://schemas.openxmlformats.org/officeDocument/2006/relationships">
+  <p:cSld>
+    <p:spTree>
+      <p:nvGrpSpPr>
+        <p:cNvPr id="1" name=""/>
+        <p:cNvGrpSpPr/>
+        <p:nvPr/>
+      </p:nvGrpSpPr>
+      <p:grpSpPr/>
+      <p:sp>
+        <p:nvSpPr>
+          <p:cNvPr id="2" name="Rectangle 1"/>
+          <p:cNvSpPr/>
+          <p:nvPr/>
+        </p:nvSpPr>
+        <p:spPr>
+          <a:xfrm>
+            <a:off x="365760" y="274320"/>
+            <a:ext cx="11430000" cy="38100"/>
+          </a:xfrm>
+          <a:prstGeom prst="rect">
+            <a:avLst/>
+          </a:prstGeom>
+          <a:solidFill>
+            <a:srgbClr val="002060"/>
+          </a:solidFill>
+          <a:ln>
+            <a:noFill/>
+          </a:ln>
+        </p:spPr>
+        <p:style>
+          <a:lnRef idx="1">
+            <a:schemeClr val="accent1"/>
+          </a:lnRef>
+          <a:fillRef idx="3">
+            <a:schemeClr val="accent1"/>
+          </a:fillRef>
+          <a:effectRef idx="2">
+            <a:schemeClr val="accent1"/>
+          </a:effectRef>
+          <a:fontRef idx="minor">
+            <a:schemeClr val="lt1"/>
+          </a:fontRef>
+        </p:style>
+        <p:txBody>
+          <a:bodyPr rtlCol="0" anchor="ctr"/>
+          <a:lstStyle/>
+          <a:p>
+            <a:pPr algn="ctr"/>
+          </a:p>
+        </p:txBody>
+      </p:sp>
+      <p:sp>
+        <p:nvSpPr>
+          <p:cNvPr id="3" name="TextBox 2"/>
+          <p:cNvSpPr txBox="1"/>
+          <p:nvPr/>
+        </p:nvSpPr>
+        <p:spPr>
+          <a:xfrm>
+            <a:off x="365760" y="365760"/>
+            <a:ext cx="9144000" cy="548640"/>
+          </a:xfrm>
+          <a:prstGeom prst="rect">
+            <a:avLst/>
+          </a:prstGeom>
+          <a:noFill/>
+        </p:spPr>
+        <p:txBody>
+          <a:bodyPr wrap="none">
+            <a:spAutoFit/>
+          </a:bodyPr>
+          <a:lstStyle/>
+          <a:p>
+            <a:pPr>
+              <a:defRPr b="1" sz="2000">
+                <a:solidFill>
+                  <a:srgbClr val="002060"/>
+                </a:solidFill>
+                <a:latin typeface="Arial"/>
+              </a:defRPr>
+            </a:pPr>
+            <a:r>
+              <a:t>Market Landscape by Region &amp; Product Line</a:t>
+            </a:r>
+          </a:p>
+        </p:txBody>
+      </p:sp>
+      <p:sp>
+        <p:nvSpPr>
+          <p:cNvPr id="4" name="TextBox 3"/>
+          <p:cNvSpPr txBox="1"/>
+          <p:nvPr/>
+        </p:nvSpPr>
+        <p:spPr>
+          <a:xfrm>
+            <a:off x="365760" y="868680"/>
+            <a:ext cx="9144000" cy="320040"/>
+          </a:xfrm>
+          <a:prstGeom prst="rect">
+            <a:avLst/>
+          </a:prstGeom>
+          <a:noFill/>
+        </p:spPr>
+        <p:txBody>
+          <a:bodyPr wrap="none">
+            <a:spAutoFit/>
+          </a:bodyPr>
+          <a:lstStyle/>
+          <a:p>
+            <a:pPr>
+              <a:defRPr sz="1100" i="1">
+                <a:solidFill>
+                  <a:srgbClr val="7F7F7F"/>
+                </a:solidFill>
+                <a:latin typeface="Arial"/>
+              </a:defRPr>
+            </a:pPr>
+            <a:r>
+              <a:t>Column width = market size ($M)  |  Height = share within region (%)</a:t>
+            </a:r>
+          </a:p>
+        </p:txBody>
+      </p:sp>
+      <p:sp>
+        <p:nvSpPr>
+          <p:cNvPr id="5" name="Rectangle 4"/>
+          <p:cNvSpPr/>
+          <p:nvPr/>
+        </p:nvSpPr>
+        <p:spPr>
+          <a:xfrm>
+            <a:off x="822960" y="1280160"/>
+            <a:ext cx="2767584" cy="1828800"/>
+          </a:xfrm>
+          <a:prstGeom prst="rect">
+            <a:avLst/>
+          </a:prstGeom>
+          <a:solidFill>
+            <a:srgbClr val="002060"/>
+          </a:solidFill>
+          <a:ln>
+            <a:noFill/>
+          </a:ln>
+        </p:spPr>
+        <p:style>
+          <a:lnRef idx="1">
+            <a:schemeClr val="accent1"/>
+          </a:lnRef>
+          <a:fillRef idx="3">
+            <a:schemeClr val="accent1"/>
+          </a:fillRef>
+          <a:effectRef idx="2">
+            <a:schemeClr val="accent1"/>
+          </a:effectRef>
+          <a:fontRef idx="minor">
+            <a:schemeClr val="lt1"/>
+          </a:fontRef>
+        </p:style>
+        <p:txBody>
+          <a:bodyPr rtlCol="0" anchor="ctr"/>
+          <a:lstStyle/>
+          <a:p>
+            <a:pPr algn="ctr"/>
+          </a:p>
+        </p:txBody>
+      </p:sp>
+      <p:sp>
+        <p:nvSpPr>
+          <p:cNvPr id="6" name="TextBox 5"/>
+          <p:cNvSpPr txBox="1"/>
+          <p:nvPr/>
+        </p:nvSpPr>
+        <p:spPr>
+          <a:xfrm>
+            <a:off x="868680" y="1307592"/>
+            <a:ext cx="2712720" cy="1773936"/>
+          </a:xfrm>
+          <a:prstGeom prst="rect">
+            <a:avLst/>
+          </a:prstGeom>
+          <a:noFill/>
+        </p:spPr>
+        <p:txBody>
+          <a:bodyPr wrap="none">
+            <a:spAutoFit/>
+          </a:bodyPr>
+          <a:lstStyle/>
+          <a:p>
+            <a:pPr>
+              <a:defRPr sz="1000" b="1">
+                <a:solidFill>
+                  <a:srgbClr val="FFFFFF"/>
+                </a:solidFill>
+                <a:latin typeface="Arial"/>
+              </a:defRPr>
+            </a:pPr>
+            <a:r>
+              <a:t>40%</a:t>
+            </a:r>
+          </a:p>
+        </p:txBody>
+      </p:sp>
+      <p:sp>
+        <p:nvSpPr>
+          <p:cNvPr id="7" name="Rectangle 6"/>
+          <p:cNvSpPr/>
+          <p:nvPr/>
+        </p:nvSpPr>
+        <p:spPr>
+          <a:xfrm>
+            <a:off x="822960" y="3108960"/>
+            <a:ext cx="2767584" cy="1371600"/>
+          </a:xfrm>
+          <a:prstGeom prst="rect">
+            <a:avLst/>
+          </a:prstGeom>
+          <a:solidFill>
+            <a:srgbClr val="1F5FA6"/>
+          </a:solidFill>
+          <a:ln>
+            <a:noFill/>
+          </a:ln>
+        </p:spPr>
+        <p:style>
+          <a:lnRef idx="1">
+            <a:schemeClr val="accent1"/>
+          </a:lnRef>
+          <a:fillRef idx="3">
+            <a:schemeClr val="accent1"/>
+          </a:fillRef>
+          <a:effectRef idx="2">
+            <a:schemeClr val="accent1"/>
+          </a:effectRef>
+          <a:fontRef idx="minor">
+            <a:schemeClr val="lt1"/>
+          </a:fontRef>
+        </p:style>
+        <p:txBody>
+          <a:bodyPr rtlCol="0" anchor="ctr"/>
+          <a:lstStyle/>
+          <a:p>
+            <a:pPr algn="ctr"/>
+          </a:p>
+        </p:txBody>
+      </p:sp>
+      <p:sp>
+        <p:nvSpPr>
+          <p:cNvPr id="8" name="TextBox 7"/>
+          <p:cNvSpPr txBox="1"/>
+          <p:nvPr/>
+        </p:nvSpPr>
+        <p:spPr>
+          <a:xfrm>
+            <a:off x="868680" y="3136392"/>
+            <a:ext cx="2712720" cy="1316736"/>
+          </a:xfrm>
+          <a:prstGeom prst="rect">
+            <a:avLst/>
+          </a:prstGeom>
+          <a:noFill/>
+        </p:spPr>
+        <p:txBody>
+          <a:bodyPr wrap="none">
+            <a:spAutoFit/>
+          </a:bodyPr>
+          <a:lstStyle/>
+          <a:p>
+            <a:pPr>
+              <a:defRPr sz="1000" b="1">
+                <a:solidFill>
+                  <a:srgbClr val="FFFFFF"/>
+                </a:solidFill>
+                <a:latin typeface="Arial"/>
+              </a:defRPr>
+            </a:pPr>
+            <a:r>
+              <a:t>30%</a:t>
+            </a:r>
+          </a:p>
+        </p:txBody>
+      </p:sp>
+      <p:sp>
+        <p:nvSpPr>
+          <p:cNvPr id="9" name="Rectangle 8"/>
+          <p:cNvSpPr/>
+          <p:nvPr/>
+        </p:nvSpPr>
+        <p:spPr>
+          <a:xfrm>
+            <a:off x="822960" y="4480560"/>
+            <a:ext cx="2767584" cy="914400"/>
+          </a:xfrm>
+          <a:prstGeom prst="rect">
+            <a:avLst/>
+          </a:prstGeom>
+          <a:solidFill>
+            <a:srgbClr val="9DC3E6"/>
+          </a:solidFill>
+          <a:ln>
+            <a:noFill/>
+          </a:ln>
+        </p:spPr>
+        <p:style>
+          <a:lnRef idx="1">
+            <a:schemeClr val="accent1"/>
+          </a:lnRef>
+          <a:fillRef idx="3">
+            <a:schemeClr val="accent1"/>
+          </a:fillRef>
+          <a:effectRef idx="2">
+            <a:schemeClr val="accent1"/>
+          </a:effectRef>
+          <a:fontRef idx="minor">
+            <a:schemeClr val="lt1"/>
+          </a:fontRef>
+        </p:style>
+        <p:txBody>
+          <a:bodyPr rtlCol="0" anchor="ctr"/>
+          <a:lstStyle/>
+          <a:p>
+            <a:pPr algn="ctr"/>
+          </a:p>
+        </p:txBody>
+      </p:sp>
+      <p:sp>
+        <p:nvSpPr>
+          <p:cNvPr id="10" name="TextBox 9"/>
+          <p:cNvSpPr txBox="1"/>
+          <p:nvPr/>
+        </p:nvSpPr>
+        <p:spPr>
+          <a:xfrm>
+            <a:off x="868680" y="4507992"/>
+            <a:ext cx="2712720" cy="859536"/>
+          </a:xfrm>
+          <a:prstGeom prst="rect">
+            <a:avLst/>
+          </a:prstGeom>
+          <a:noFill/>
+        </p:spPr>
+        <p:txBody>
+          <a:bodyPr wrap="none">
+            <a:spAutoFit/>
+          </a:bodyPr>
+          <a:lstStyle/>
+          <a:p>
+            <a:pPr>
+              <a:defRPr sz="1000" b="1">
+                <a:solidFill>
+                  <a:srgbClr val="000000"/>
+                </a:solidFill>
+                <a:latin typeface="Arial"/>
+              </a:defRPr>
+            </a:pPr>
+            <a:r>
+              <a:t>20%</a:t>
+            </a:r>
+          </a:p>
+        </p:txBody>
+      </p:sp>
+      <p:sp>
+        <p:nvSpPr>
+          <p:cNvPr id="11" name="Rectangle 10"/>
+          <p:cNvSpPr/>
+          <p:nvPr/>
+        </p:nvSpPr>
+        <p:spPr>
+          <a:xfrm>
+            <a:off x="822960" y="5394960"/>
+            <a:ext cx="2767584" cy="457200"/>
+          </a:xfrm>
+          <a:prstGeom prst="rect">
+            <a:avLst/>
+          </a:prstGeom>
+          <a:solidFill>
+            <a:srgbClr val="D9D9D9"/>
+          </a:solidFill>
+          <a:ln>
+            <a:noFill/>
+          </a:ln>
+        </p:spPr>
+        <p:style>
+          <a:lnRef idx="1">
+            <a:schemeClr val="accent1"/>
+          </a:lnRef>
+          <a:fillRef idx="3">
+            <a:schemeClr val="accent1"/>
+          </a:fillRef>
+          <a:effectRef idx="2">
+            <a:schemeClr val="accent1"/>
+          </a:effectRef>
+          <a:fontRef idx="minor">
+            <a:schemeClr val="lt1"/>
+          </a:fontRef>
+        </p:style>
+        <p:txBody>
+          <a:bodyPr rtlCol="0" anchor="ctr"/>
+          <a:lstStyle/>
+          <a:p>
+            <a:pPr algn="ctr"/>
+          </a:p>
+        </p:txBody>
+      </p:sp>
+      <p:sp>
+        <p:nvSpPr>
+          <p:cNvPr id="12" name="TextBox 11"/>
+          <p:cNvSpPr txBox="1"/>
+          <p:nvPr/>
+        </p:nvSpPr>
+        <p:spPr>
+          <a:xfrm>
+            <a:off x="868680" y="5422392"/>
+            <a:ext cx="2712720" cy="402336"/>
+          </a:xfrm>
+          <a:prstGeom prst="rect">
+            <a:avLst/>
+          </a:prstGeom>
+          <a:noFill/>
+        </p:spPr>
+        <p:txBody>
+          <a:bodyPr wrap="none">
+            <a:spAutoFit/>
+          </a:bodyPr>
+          <a:lstStyle/>
+          <a:p>
+            <a:pPr>
+              <a:defRPr sz="1000" b="1">
+                <a:solidFill>
+                  <a:srgbClr val="000000"/>
+                </a:solidFill>
+                <a:latin typeface="Arial"/>
+              </a:defRPr>
+            </a:pPr>
+            <a:r>
+              <a:t>10%</a:t>
+            </a:r>
+          </a:p>
+        </p:txBody>
+      </p:sp>
+      <p:sp>
+        <p:nvSpPr>
+          <p:cNvPr id="13" name="TextBox 12"/>
+          <p:cNvSpPr txBox="1"/>
+          <p:nvPr/>
+        </p:nvSpPr>
+        <p:spPr>
+          <a:xfrm>
+            <a:off x="822960" y="5943600"/>
+            <a:ext cx="2804160" cy="457200"/>
+          </a:xfrm>
+          <a:prstGeom prst="rect">
+            <a:avLst/>
+          </a:prstGeom>
+          <a:noFill/>
+        </p:spPr>
+        <p:txBody>
+          <a:bodyPr wrap="square">
+            <a:spAutoFit/>
+          </a:bodyPr>
+          <a:lstStyle/>
+          <a:p>
+            <a:pPr algn="ctr">
+              <a:defRPr sz="900" b="1">
+                <a:solidFill>
+                  <a:srgbClr val="002060"/>
+                </a:solidFill>
+                <a:latin typeface="Arial"/>
+              </a:defRPr>
+            </a:pPr>
+            <a:r>
+              <a:t>Europe</a:t>
+            </a:r>
+            <a:br/>
+            <a:r>
+              <a:t>$320M</a:t>
+            </a:r>
+          </a:p>
+        </p:txBody>
+      </p:sp>
+      <p:sp>
+        <p:nvSpPr>
+          <p:cNvPr id="14" name="Rectangle 13"/>
+          <p:cNvSpPr/>
+          <p:nvPr/>
+        </p:nvSpPr>
+        <p:spPr>
+          <a:xfrm>
+            <a:off x="3627120" y="1280160"/>
+            <a:ext cx="4169664" cy="1600200"/>
+          </a:xfrm>
+          <a:prstGeom prst="rect">
+            <a:avLst/>
+          </a:prstGeom>
+          <a:solidFill>
+            <a:srgbClr val="002060"/>
+          </a:solidFill>
+          <a:ln>
+            <a:noFill/>
+          </a:ln>
+        </p:spPr>
+        <p:style>
+          <a:lnRef idx="1">
+            <a:schemeClr val="accent1"/>
+          </a:lnRef>
+          <a:fillRef idx="3">
+            <a:schemeClr val="accent1"/>
+          </a:fillRef>
+          <a:effectRef idx="2">
+            <a:schemeClr val="accent1"/>
+          </a:effectRef>
+          <a:fontRef idx="minor">
+            <a:schemeClr val="lt1"/>
+          </a:fontRef>
+        </p:style>
+        <p:txBody>
+          <a:bodyPr rtlCol="0" anchor="ctr"/>
+          <a:lstStyle/>
+          <a:p>
+            <a:pPr algn="ctr"/>
+          </a:p>
+        </p:txBody>
+      </p:sp>
+      <p:sp>
+        <p:nvSpPr>
+          <p:cNvPr id="15" name="TextBox 14"/>
+          <p:cNvSpPr txBox="1"/>
+          <p:nvPr/>
+        </p:nvSpPr>
+        <p:spPr>
+          <a:xfrm>
+            <a:off x="3672840" y="1307592"/>
+            <a:ext cx="4114800" cy="1545336"/>
+          </a:xfrm>
+          <a:prstGeom prst="rect">
+            <a:avLst/>
+          </a:prstGeom>
+          <a:noFill/>
+        </p:spPr>
+        <p:txBody>
+          <a:bodyPr wrap="none">
+            <a:spAutoFit/>
+          </a:bodyPr>
+          <a:lstStyle/>
+          <a:p>
+            <a:pPr>
+              <a:defRPr sz="1000" b="1">
+                <a:solidFill>
+                  <a:srgbClr val="FFFFFF"/>
+                </a:solidFill>
+                <a:latin typeface="Arial"/>
+              </a:defRPr>
+            </a:pPr>
+            <a:r>
+              <a:t>35%</a:t>
+            </a:r>
+          </a:p>
+        </p:txBody>
+      </p:sp>
+      <p:sp>
+        <p:nvSpPr>
+          <p:cNvPr id="16" name="Rectangle 15"/>
+          <p:cNvSpPr/>
+          <p:nvPr/>
+        </p:nvSpPr>
+        <p:spPr>
+          <a:xfrm>
+            <a:off x="3627120" y="2880360"/>
+            <a:ext cx="4169664" cy="1371600"/>
+          </a:xfrm>
+          <a:prstGeom prst="rect">
+            <a:avLst/>
+          </a:prstGeom>
+          <a:solidFill>
+            <a:srgbClr val="1F5FA6"/>
+          </a:solidFill>
+          <a:ln>
+            <a:noFill/>
+          </a:ln>
+        </p:spPr>
+        <p:style>
+          <a:lnRef idx="1">
+            <a:schemeClr val="accent1"/>
+          </a:lnRef>
+          <a:fillRef idx="3">
+            <a:schemeClr val="accent1"/>
+          </a:fillRef>
+          <a:effectRef idx="2">
+            <a:schemeClr val="accent1"/>
+          </a:effectRef>
+          <a:fontRef idx="minor">
+            <a:schemeClr val="lt1"/>
+          </a:fontRef>
+        </p:style>
+        <p:txBody>
+          <a:bodyPr rtlCol="0" anchor="ctr"/>
+          <a:lstStyle/>
+          <a:p>
+            <a:pPr algn="ctr"/>
+          </a:p>
+        </p:txBody>
+      </p:sp>
+      <p:sp>
+        <p:nvSpPr>
+          <p:cNvPr id="17" name="TextBox 16"/>
+          <p:cNvSpPr txBox="1"/>
+          <p:nvPr/>
+        </p:nvSpPr>
+        <p:spPr>
+          <a:xfrm>
+            <a:off x="3672840" y="2907792"/>
+            <a:ext cx="4114800" cy="1316736"/>
+          </a:xfrm>
+          <a:prstGeom prst="rect">
+            <a:avLst/>
+          </a:prstGeom>
+          <a:noFill/>
+        </p:spPr>
+        <p:txBody>
+          <a:bodyPr wrap="none">
+            <a:spAutoFit/>
+          </a:bodyPr>
+          <a:lstStyle/>
+          <a:p>
+            <a:pPr>
+              <a:defRPr sz="1000" b="1">
+                <a:solidFill>
+                  <a:srgbClr val="FFFFFF"/>
+                </a:solidFill>
+                <a:latin typeface="Arial"/>
+              </a:defRPr>
+            </a:pPr>
+            <a:r>
+              <a:t>30%</a:t>
+            </a:r>
+          </a:p>
+        </p:txBody>
+      </p:sp>
+      <p:sp>
+        <p:nvSpPr>
+          <p:cNvPr id="18" name="Rectangle 17"/>
+          <p:cNvSpPr/>
+          <p:nvPr/>
+        </p:nvSpPr>
+        <p:spPr>
+          <a:xfrm>
+            <a:off x="3627120" y="4251960"/>
+            <a:ext cx="4169664" cy="1143000"/>
+          </a:xfrm>
+          <a:prstGeom prst="rect">
+            <a:avLst/>
+          </a:prstGeom>
+          <a:solidFill>
+            <a:srgbClr val="9DC3E6"/>
+          </a:solidFill>
+          <a:ln>
+            <a:noFill/>
+          </a:ln>
+        </p:spPr>
+        <p:style>
+          <a:lnRef idx="1">
+            <a:schemeClr val="accent1"/>
+          </a:lnRef>
+          <a:fillRef idx="3">
+            <a:schemeClr val="accent1"/>
+          </a:fillRef>
+          <a:effectRef idx="2">
+            <a:schemeClr val="accent1"/>
+          </a:effectRef>
+          <a:fontRef idx="minor">
+            <a:schemeClr val="lt1"/>
+          </a:fontRef>
+        </p:style>
+        <p:txBody>
+          <a:bodyPr rtlCol="0" anchor="ctr"/>
+          <a:lstStyle/>
+          <a:p>
+            <a:pPr algn="ctr"/>
+          </a:p>
+        </p:txBody>
+      </p:sp>
+      <p:sp>
+        <p:nvSpPr>
+          <p:cNvPr id="19" name="TextBox 18"/>
+          <p:cNvSpPr txBox="1"/>
+          <p:nvPr/>
+        </p:nvSpPr>
+        <p:spPr>
+          <a:xfrm>
+            <a:off x="3672840" y="4279392"/>
+            <a:ext cx="4114800" cy="1088136"/>
+          </a:xfrm>
+          <a:prstGeom prst="rect">
+            <a:avLst/>
+          </a:prstGeom>
+          <a:noFill/>
+        </p:spPr>
+        <p:txBody>
+          <a:bodyPr wrap="none">
+            <a:spAutoFit/>
+          </a:bodyPr>
+          <a:lstStyle/>
+          <a:p>
+            <a:pPr>
+              <a:defRPr sz="1000" b="1">
+                <a:solidFill>
+                  <a:srgbClr val="000000"/>
+                </a:solidFill>
+                <a:latin typeface="Arial"/>
+              </a:defRPr>
+            </a:pPr>
+            <a:r>
+              <a:t>25%</a:t>
+            </a:r>
+          </a:p>
+        </p:txBody>
+      </p:sp>
+      <p:sp>
+        <p:nvSpPr>
+          <p:cNvPr id="20" name="Rectangle 19"/>
+          <p:cNvSpPr/>
+          <p:nvPr/>
+        </p:nvSpPr>
+        <p:spPr>
+          <a:xfrm>
+            <a:off x="3627120" y="5394960"/>
+            <a:ext cx="4169664" cy="457200"/>
+          </a:xfrm>
+          <a:prstGeom prst="rect">
+            <a:avLst/>
+          </a:prstGeom>
+          <a:solidFill>
+            <a:srgbClr val="D9D9D9"/>
+          </a:solidFill>
+          <a:ln>
+            <a:noFill/>
+          </a:ln>
+        </p:spPr>
+        <p:style>
+          <a:lnRef idx="1">
+            <a:schemeClr val="accent1"/>
+          </a:lnRef>
+          <a:fillRef idx="3">
+            <a:schemeClr val="accent1"/>
+          </a:fillRef>
+          <a:effectRef idx="2">
+            <a:schemeClr val="accent1"/>
+          </a:effectRef>
+          <a:fontRef idx="minor">
+            <a:schemeClr val="lt1"/>
+          </a:fontRef>
+        </p:style>
+        <p:txBody>
+          <a:bodyPr rtlCol="0" anchor="ctr"/>
+          <a:lstStyle/>
+          <a:p>
+            <a:pPr algn="ctr"/>
+          </a:p>
+        </p:txBody>
+      </p:sp>
+      <p:sp>
+        <p:nvSpPr>
+          <p:cNvPr id="21" name="TextBox 20"/>
+          <p:cNvSpPr txBox="1"/>
+          <p:nvPr/>
+        </p:nvSpPr>
+        <p:spPr>
+          <a:xfrm>
+            <a:off x="3672840" y="5422392"/>
+            <a:ext cx="4114800" cy="402336"/>
+          </a:xfrm>
+          <a:prstGeom prst="rect">
+            <a:avLst/>
+          </a:prstGeom>
+          <a:noFill/>
+        </p:spPr>
+        <p:txBody>
+          <a:bodyPr wrap="none">
+            <a:spAutoFit/>
+          </a:bodyPr>
+          <a:lstStyle/>
+          <a:p>
+            <a:pPr>
+              <a:defRPr sz="1000" b="1">
+                <a:solidFill>
+                  <a:srgbClr val="000000"/>
+                </a:solidFill>
+                <a:latin typeface="Arial"/>
+              </a:defRPr>
+            </a:pPr>
+            <a:r>
+              <a:t>10%</a:t>
+            </a:r>
+          </a:p>
+        </p:txBody>
+      </p:sp>
+      <p:sp>
+        <p:nvSpPr>
+          <p:cNvPr id="22" name="TextBox 21"/>
+          <p:cNvSpPr txBox="1"/>
+          <p:nvPr/>
+        </p:nvSpPr>
+        <p:spPr>
+          <a:xfrm>
+            <a:off x="3627120" y="5943600"/>
+            <a:ext cx="4206240" cy="457200"/>
+          </a:xfrm>
+          <a:prstGeom prst="rect">
+            <a:avLst/>
+          </a:prstGeom>
+          <a:noFill/>
+        </p:spPr>
+        <p:txBody>
+          <a:bodyPr wrap="square">
+            <a:spAutoFit/>
+          </a:bodyPr>
+          <a:lstStyle/>
+          <a:p>
+            <a:pPr algn="ctr">
+              <a:defRPr sz="900" b="1">
+                <a:solidFill>
+                  <a:srgbClr val="002060"/>
+                </a:solidFill>
+                <a:latin typeface="Arial"/>
+              </a:defRPr>
+            </a:pPr>
+            <a:r>
+              <a:t>North America</a:t>
+            </a:r>
+            <a:br/>
+            <a:r>
+              <a:t>$480M</a:t>
+            </a:r>
+          </a:p>
+        </p:txBody>
+      </p:sp>
+      <p:sp>
+        <p:nvSpPr>
+          <p:cNvPr id="23" name="Rectangle 22"/>
+          <p:cNvSpPr/>
+          <p:nvPr/>
+        </p:nvSpPr>
+        <p:spPr>
+          <a:xfrm>
+            <a:off x="7833360" y="1280160"/>
+            <a:ext cx="2241804" cy="1143000"/>
+          </a:xfrm>
+          <a:prstGeom prst="rect">
+            <a:avLst/>
+          </a:prstGeom>
+          <a:solidFill>
+            <a:srgbClr val="002060"/>
+          </a:solidFill>
+          <a:ln>
+            <a:noFill/>
+          </a:ln>
+        </p:spPr>
+        <p:style>
+          <a:lnRef idx="1">
+            <a:schemeClr val="accent1"/>
+          </a:lnRef>
+          <a:fillRef idx="3">
+            <a:schemeClr val="accent1"/>
+          </a:fillRef>
+          <a:effectRef idx="2">
+            <a:schemeClr val="accent1"/>
+          </a:effectRef>
+          <a:fontRef idx="minor">
+            <a:schemeClr val="lt1"/>
+          </a:fontRef>
+        </p:style>
+        <p:txBody>
+          <a:bodyPr rtlCol="0" anchor="ctr"/>
+          <a:lstStyle/>
+          <a:p>
+            <a:pPr algn="ctr"/>
+          </a:p>
+        </p:txBody>
+      </p:sp>
+      <p:sp>
+        <p:nvSpPr>
+          <p:cNvPr id="24" name="TextBox 23"/>
+          <p:cNvSpPr txBox="1"/>
+          <p:nvPr/>
+        </p:nvSpPr>
+        <p:spPr>
+          <a:xfrm>
+            <a:off x="7879080" y="1307592"/>
+            <a:ext cx="2186940" cy="1088136"/>
+          </a:xfrm>
+          <a:prstGeom prst="rect">
+            <a:avLst/>
+          </a:prstGeom>
+          <a:noFill/>
+        </p:spPr>
+        <p:txBody>
+          <a:bodyPr wrap="none">
+            <a:spAutoFit/>
+          </a:bodyPr>
+          <a:lstStyle/>
+          <a:p>
+            <a:pPr>
+              <a:defRPr sz="1000" b="1">
+                <a:solidFill>
+                  <a:srgbClr val="FFFFFF"/>
+                </a:solidFill>
+                <a:latin typeface="Arial"/>
+              </a:defRPr>
+            </a:pPr>
+            <a:r>
+              <a:t>25%</a:t>
+            </a:r>
+          </a:p>
+        </p:txBody>
+      </p:sp>
+      <p:sp>
+        <p:nvSpPr>
+          <p:cNvPr id="25" name="Rectangle 24"/>
+          <p:cNvSpPr/>
+          <p:nvPr/>
+        </p:nvSpPr>
+        <p:spPr>
+          <a:xfrm>
+            <a:off x="7833360" y="2423160"/>
+            <a:ext cx="2241804" cy="1600200"/>
+          </a:xfrm>
+          <a:prstGeom prst="rect">
+            <a:avLst/>
+          </a:prstGeom>
+          <a:solidFill>
+            <a:srgbClr val="1F5FA6"/>
+          </a:solidFill>
+          <a:ln>
+            <a:noFill/>
+          </a:ln>
+        </p:spPr>
+        <p:style>
+          <a:lnRef idx="1">
+            <a:schemeClr val="accent1"/>
+          </a:lnRef>
+          <a:fillRef idx="3">
+            <a:schemeClr val="accent1"/>
+          </a:fillRef>
+          <a:effectRef idx="2">
+            <a:schemeClr val="accent1"/>
+          </a:effectRef>
+          <a:fontRef idx="minor">
+            <a:schemeClr val="lt1"/>
+          </a:fontRef>
+        </p:style>
+        <p:txBody>
+          <a:bodyPr rtlCol="0" anchor="ctr"/>
+          <a:lstStyle/>
+          <a:p>
+            <a:pPr algn="ctr"/>
+          </a:p>
+        </p:txBody>
+      </p:sp>
+      <p:sp>
+        <p:nvSpPr>
+          <p:cNvPr id="26" name="TextBox 25"/>
+          <p:cNvSpPr txBox="1"/>
+          <p:nvPr/>
+        </p:nvSpPr>
+        <p:spPr>
+          <a:xfrm>
+            <a:off x="7879080" y="2450592"/>
+            <a:ext cx="2186940" cy="1545336"/>
+          </a:xfrm>
+          <a:prstGeom prst="rect">
+            <a:avLst/>
+          </a:prstGeom>
+          <a:noFill/>
+        </p:spPr>
+        <p:txBody>
+          <a:bodyPr wrap="none">
+            <a:spAutoFit/>
+          </a:bodyPr>
+          <a:lstStyle/>
+          <a:p>
+            <a:pPr>
+              <a:defRPr sz="1000" b="1">
+                <a:solidFill>
+                  <a:srgbClr val="FFFFFF"/>
+                </a:solidFill>
+                <a:latin typeface="Arial"/>
+              </a:defRPr>
+            </a:pPr>
+            <a:r>
+              <a:t>35%</a:t>
+            </a:r>
+          </a:p>
+        </p:txBody>
+      </p:sp>
+      <p:sp>
+        <p:nvSpPr>
+          <p:cNvPr id="27" name="Rectangle 26"/>
+          <p:cNvSpPr/>
+          <p:nvPr/>
+        </p:nvSpPr>
+        <p:spPr>
+          <a:xfrm>
+            <a:off x="7833360" y="4023360"/>
+            <a:ext cx="2241804" cy="1371600"/>
+          </a:xfrm>
+          <a:prstGeom prst="rect">
+            <a:avLst/>
+          </a:prstGeom>
+          <a:solidFill>
+            <a:srgbClr val="9DC3E6"/>
+          </a:solidFill>
+          <a:ln>
+            <a:noFill/>
+          </a:ln>
+        </p:spPr>
+        <p:style>
+          <a:lnRef idx="1">
+            <a:schemeClr val="accent1"/>
+          </a:lnRef>
+          <a:fillRef idx="3">
+            <a:schemeClr val="accent1"/>
+          </a:fillRef>
+          <a:effectRef idx="2">
+            <a:schemeClr val="accent1"/>
+          </a:effectRef>
+          <a:fontRef idx="minor">
+            <a:schemeClr val="lt1"/>
+          </a:fontRef>
+        </p:style>
+        <p:txBody>
+          <a:bodyPr rtlCol="0" anchor="ctr"/>
+          <a:lstStyle/>
+          <a:p>
+            <a:pPr algn="ctr"/>
+          </a:p>
+        </p:txBody>
+      </p:sp>
+      <p:sp>
+        <p:nvSpPr>
+          <p:cNvPr id="28" name="TextBox 27"/>
+          <p:cNvSpPr txBox="1"/>
+          <p:nvPr/>
+        </p:nvSpPr>
+        <p:spPr>
+          <a:xfrm>
+            <a:off x="7879080" y="4050792"/>
+            <a:ext cx="2186940" cy="1316736"/>
+          </a:xfrm>
+          <a:prstGeom prst="rect">
+            <a:avLst/>
+          </a:prstGeom>
+          <a:noFill/>
+        </p:spPr>
+        <p:txBody>
+          <a:bodyPr wrap="none">
+            <a:spAutoFit/>
+          </a:bodyPr>
+          <a:lstStyle/>
+          <a:p>
+            <a:pPr>
+              <a:defRPr sz="1000" b="1">
+                <a:solidFill>
+                  <a:srgbClr val="000000"/>
+                </a:solidFill>
+                <a:latin typeface="Arial"/>
+              </a:defRPr>
+            </a:pPr>
+            <a:r>
+              <a:t>30%</a:t>
+            </a:r>
+          </a:p>
+        </p:txBody>
+      </p:sp>
+      <p:sp>
+        <p:nvSpPr>
+          <p:cNvPr id="29" name="Rectangle 28"/>
+          <p:cNvSpPr/>
+          <p:nvPr/>
+        </p:nvSpPr>
+        <p:spPr>
+          <a:xfrm>
+            <a:off x="7833360" y="5394960"/>
+            <a:ext cx="2241804" cy="457200"/>
+          </a:xfrm>
+          <a:prstGeom prst="rect">
+            <a:avLst/>
+          </a:prstGeom>
+          <a:solidFill>
+            <a:srgbClr val="D9D9D9"/>
+          </a:solidFill>
+          <a:ln>
+            <a:noFill/>
+          </a:ln>
+        </p:spPr>
+        <p:style>
+          <a:lnRef idx="1">
+            <a:schemeClr val="accent1"/>
+          </a:lnRef>
+          <a:fillRef idx="3">
+            <a:schemeClr val="accent1"/>
+          </a:fillRef>
+          <a:effectRef idx="2">
+            <a:schemeClr val="accent1"/>
+          </a:effectRef>
+          <a:fontRef idx="minor">
+            <a:schemeClr val="lt1"/>
+          </a:fontRef>
+        </p:style>
+        <p:txBody>
+          <a:bodyPr rtlCol="0" anchor="ctr"/>
+          <a:lstStyle/>
+          <a:p>
+            <a:pPr algn="ctr"/>
+          </a:p>
+        </p:txBody>
+      </p:sp>
+      <p:sp>
+        <p:nvSpPr>
+          <p:cNvPr id="30" name="TextBox 29"/>
+          <p:cNvSpPr txBox="1"/>
+          <p:nvPr/>
+        </p:nvSpPr>
+        <p:spPr>
+          <a:xfrm>
+            <a:off x="7879080" y="5422392"/>
+            <a:ext cx="2186940" cy="402336"/>
+          </a:xfrm>
+          <a:prstGeom prst="rect">
+            <a:avLst/>
+          </a:prstGeom>
+          <a:noFill/>
+        </p:spPr>
+        <p:txBody>
+          <a:bodyPr wrap="none">
+            <a:spAutoFit/>
+          </a:bodyPr>
+          <a:lstStyle/>
+          <a:p>
+            <a:pPr>
+              <a:defRPr sz="1000" b="1">
+                <a:solidFill>
+                  <a:srgbClr val="000000"/>
+                </a:solidFill>
+                <a:latin typeface="Arial"/>
+              </a:defRPr>
+            </a:pPr>
+            <a:r>
+              <a:t>10%</a:t>
+            </a:r>
+          </a:p>
+        </p:txBody>
+      </p:sp>
+      <p:sp>
+        <p:nvSpPr>
+          <p:cNvPr id="31" name="TextBox 30"/>
+          <p:cNvSpPr txBox="1"/>
+          <p:nvPr/>
+        </p:nvSpPr>
+        <p:spPr>
+          <a:xfrm>
+            <a:off x="7833360" y="5943600"/>
+            <a:ext cx="2278380" cy="457200"/>
+          </a:xfrm>
+          <a:prstGeom prst="rect">
+            <a:avLst/>
+          </a:prstGeom>
+          <a:noFill/>
+        </p:spPr>
+        <p:txBody>
+          <a:bodyPr wrap="square">
+            <a:spAutoFit/>
+          </a:bodyPr>
+          <a:lstStyle/>
+          <a:p>
+            <a:pPr algn="ctr">
+              <a:defRPr sz="900" b="1">
+                <a:solidFill>
+                  <a:srgbClr val="002060"/>
+                </a:solidFill>
+                <a:latin typeface="Arial"/>
+              </a:defRPr>
+            </a:pPr>
+            <a:r>
+              <a:t>Asia Pacific</a:t>
+            </a:r>
+            <a:br/>
+            <a:r>
+              <a:t>$260M</a:t>
+            </a:r>
+          </a:p>
+        </p:txBody>
+      </p:sp>
+      <p:sp>
+        <p:nvSpPr>
+          <p:cNvPr id="32" name="Rectangle 31"/>
+          <p:cNvSpPr/>
+          <p:nvPr/>
+        </p:nvSpPr>
+        <p:spPr>
+          <a:xfrm>
+            <a:off x="10111740" y="1280160"/>
+            <a:ext cx="1190244" cy="914400"/>
+          </a:xfrm>
+          <a:prstGeom prst="rect">
+            <a:avLst/>
+          </a:prstGeom>
+          <a:solidFill>
+            <a:srgbClr val="002060"/>
+          </a:solidFill>
+          <a:ln>
+            <a:noFill/>
+          </a:ln>
+        </p:spPr>
+        <p:style>
+          <a:lnRef idx="1">
+            <a:schemeClr val="accent1"/>
+          </a:lnRef>
+          <a:fillRef idx="3">
+            <a:schemeClr val="accent1"/>
+          </a:fillRef>
+          <a:effectRef idx="2">
+            <a:schemeClr val="accent1"/>
+          </a:effectRef>
+          <a:fontRef idx="minor">
+            <a:schemeClr val="lt1"/>
+          </a:fontRef>
+        </p:style>
+        <p:txBody>
+          <a:bodyPr rtlCol="0" anchor="ctr"/>
+          <a:lstStyle/>
+          <a:p>
+            <a:pPr algn="ctr"/>
+          </a:p>
+        </p:txBody>
+      </p:sp>
+      <p:sp>
+        <p:nvSpPr>
+          <p:cNvPr id="33" name="TextBox 32"/>
+          <p:cNvSpPr txBox="1"/>
+          <p:nvPr/>
+        </p:nvSpPr>
+        <p:spPr>
+          <a:xfrm>
+            <a:off x="10157460" y="1307592"/>
+            <a:ext cx="1135380" cy="859536"/>
+          </a:xfrm>
+          <a:prstGeom prst="rect">
+            <a:avLst/>
+          </a:prstGeom>
+          <a:noFill/>
+        </p:spPr>
+        <p:txBody>
+          <a:bodyPr wrap="none">
+            <a:spAutoFit/>
+          </a:bodyPr>
+          <a:lstStyle/>
+          <a:p>
+            <a:pPr>
+              <a:defRPr sz="1000" b="1">
+                <a:solidFill>
+                  <a:srgbClr val="FFFFFF"/>
+                </a:solidFill>
+                <a:latin typeface="Arial"/>
+              </a:defRPr>
+            </a:pPr>
+            <a:r>
+              <a:t>20%</a:t>
+            </a:r>
+          </a:p>
+        </p:txBody>
+      </p:sp>
+      <p:sp>
+        <p:nvSpPr>
+          <p:cNvPr id="34" name="Rectangle 33"/>
+          <p:cNvSpPr/>
+          <p:nvPr/>
+        </p:nvSpPr>
+        <p:spPr>
+          <a:xfrm>
+            <a:off x="10111740" y="2194560"/>
+            <a:ext cx="1190244" cy="1371600"/>
+          </a:xfrm>
+          <a:prstGeom prst="rect">
+            <a:avLst/>
+          </a:prstGeom>
+          <a:solidFill>
+            <a:srgbClr val="1F5FA6"/>
+          </a:solidFill>
+          <a:ln>
+            <a:noFill/>
+          </a:ln>
+        </p:spPr>
+        <p:style>
+          <a:lnRef idx="1">
+            <a:schemeClr val="accent1"/>
+          </a:lnRef>
+          <a:fillRef idx="3">
+            <a:schemeClr val="accent1"/>
+          </a:fillRef>
+          <a:effectRef idx="2">
+            <a:schemeClr val="accent1"/>
+          </a:effectRef>
+          <a:fontRef idx="minor">
+            <a:schemeClr val="lt1"/>
+          </a:fontRef>
+        </p:style>
+        <p:txBody>
+          <a:bodyPr rtlCol="0" anchor="ctr"/>
+          <a:lstStyle/>
+          <a:p>
+            <a:pPr algn="ctr"/>
+          </a:p>
+        </p:txBody>
+      </p:sp>
+      <p:sp>
+        <p:nvSpPr>
+          <p:cNvPr id="35" name="TextBox 34"/>
+          <p:cNvSpPr txBox="1"/>
+          <p:nvPr/>
+        </p:nvSpPr>
+        <p:spPr>
+          <a:xfrm>
+            <a:off x="10157460" y="2221992"/>
+            <a:ext cx="1135380" cy="1316736"/>
+          </a:xfrm>
+          <a:prstGeom prst="rect">
+            <a:avLst/>
+          </a:prstGeom>
+          <a:noFill/>
+        </p:spPr>
+        <p:txBody>
+          <a:bodyPr wrap="none">
+            <a:spAutoFit/>
+          </a:bodyPr>
+          <a:lstStyle/>
+          <a:p>
+            <a:pPr>
+              <a:defRPr sz="1000" b="1">
+                <a:solidFill>
+                  <a:srgbClr val="FFFFFF"/>
+                </a:solidFill>
+                <a:latin typeface="Arial"/>
+              </a:defRPr>
+            </a:pPr>
+            <a:r>
+              <a:t>30%</a:t>
+            </a:r>
+          </a:p>
+        </p:txBody>
+      </p:sp>
+      <p:sp>
+        <p:nvSpPr>
+          <p:cNvPr id="36" name="Rectangle 35"/>
+          <p:cNvSpPr/>
+          <p:nvPr/>
+        </p:nvSpPr>
+        <p:spPr>
+          <a:xfrm>
+            <a:off x="10111740" y="3566160"/>
+            <a:ext cx="1190244" cy="1600200"/>
+          </a:xfrm>
+          <a:prstGeom prst="rect">
+            <a:avLst/>
+          </a:prstGeom>
+          <a:solidFill>
+            <a:srgbClr val="9DC3E6"/>
+          </a:solidFill>
+          <a:ln>
+            <a:noFill/>
+          </a:ln>
+        </p:spPr>
+        <p:style>
+          <a:lnRef idx="1">
+            <a:schemeClr val="accent1"/>
+          </a:lnRef>
+          <a:fillRef idx="3">
+            <a:schemeClr val="accent1"/>
+          </a:fillRef>
+          <a:effectRef idx="2">
+            <a:schemeClr val="accent1"/>
+          </a:effectRef>
+          <a:fontRef idx="minor">
+            <a:schemeClr val="lt1"/>
+          </a:fontRef>
+        </p:style>
+        <p:txBody>
+          <a:bodyPr rtlCol="0" anchor="ctr"/>
+          <a:lstStyle/>
+          <a:p>
+            <a:pPr algn="ctr"/>
+          </a:p>
+        </p:txBody>
+      </p:sp>
+      <p:sp>
+        <p:nvSpPr>
+          <p:cNvPr id="37" name="TextBox 36"/>
+          <p:cNvSpPr txBox="1"/>
+          <p:nvPr/>
+        </p:nvSpPr>
+        <p:spPr>
+          <a:xfrm>
+            <a:off x="10157460" y="3593592"/>
+            <a:ext cx="1135380" cy="1545336"/>
+          </a:xfrm>
+          <a:prstGeom prst="rect">
+            <a:avLst/>
+          </a:prstGeom>
+          <a:noFill/>
+        </p:spPr>
+        <p:txBody>
+          <a:bodyPr wrap="none">
+            <a:spAutoFit/>
+          </a:bodyPr>
+          <a:lstStyle/>
+          <a:p>
+            <a:pPr>
+              <a:defRPr sz="1000" b="1">
+                <a:solidFill>
+                  <a:srgbClr val="000000"/>
+                </a:solidFill>
+                <a:latin typeface="Arial"/>
+              </a:defRPr>
+            </a:pPr>
+            <a:r>
+              <a:t>35%</a:t>
+            </a:r>
+          </a:p>
+        </p:txBody>
+      </p:sp>
+      <p:sp>
+        <p:nvSpPr>
+          <p:cNvPr id="38" name="Rectangle 37"/>
+          <p:cNvSpPr/>
+          <p:nvPr/>
+        </p:nvSpPr>
+        <p:spPr>
+          <a:xfrm>
+            <a:off x="10111740" y="5166360"/>
+            <a:ext cx="1190244" cy="685800"/>
+          </a:xfrm>
+          <a:prstGeom prst="rect">
+            <a:avLst/>
+          </a:prstGeom>
+          <a:solidFill>
+            <a:srgbClr val="D9D9D9"/>
+          </a:solidFill>
+          <a:ln>
+            <a:noFill/>
+          </a:ln>
+        </p:spPr>
+        <p:style>
+          <a:lnRef idx="1">
+            <a:schemeClr val="accent1"/>
+          </a:lnRef>
+          <a:fillRef idx="3">
+            <a:schemeClr val="accent1"/>
+          </a:fillRef>
+          <a:effectRef idx="2">
+            <a:schemeClr val="accent1"/>
+          </a:effectRef>
+          <a:fontRef idx="minor">
+            <a:schemeClr val="lt1"/>
+          </a:fontRef>
+        </p:style>
+        <p:txBody>
+          <a:bodyPr rtlCol="0" anchor="ctr"/>
+          <a:lstStyle/>
+          <a:p>
+            <a:pPr algn="ctr"/>
+          </a:p>
+        </p:txBody>
+      </p:sp>
+      <p:sp>
+        <p:nvSpPr>
+          <p:cNvPr id="39" name="TextBox 38"/>
+          <p:cNvSpPr txBox="1"/>
+          <p:nvPr/>
+        </p:nvSpPr>
+        <p:spPr>
+          <a:xfrm>
+            <a:off x="10157460" y="5193792"/>
+            <a:ext cx="1135380" cy="630936"/>
+          </a:xfrm>
+          <a:prstGeom prst="rect">
+            <a:avLst/>
+          </a:prstGeom>
+          <a:noFill/>
+        </p:spPr>
+        <p:txBody>
+          <a:bodyPr wrap="none">
+            <a:spAutoFit/>
+          </a:bodyPr>
+          <a:lstStyle/>
+          <a:p>
+            <a:pPr>
+              <a:defRPr sz="1000" b="1">
+                <a:solidFill>
+                  <a:srgbClr val="000000"/>
+                </a:solidFill>
+                <a:latin typeface="Arial"/>
+              </a:defRPr>
+            </a:pPr>
+            <a:r>
+              <a:t>15%</a:t>
+            </a:r>
+          </a:p>
+        </p:txBody>
+      </p:sp>
+      <p:sp>
+        <p:nvSpPr>
+          <p:cNvPr id="40" name="TextBox 39"/>
+          <p:cNvSpPr txBox="1"/>
+          <p:nvPr/>
+        </p:nvSpPr>
+        <p:spPr>
+          <a:xfrm>
+            <a:off x="10111740" y="5943600"/>
+            <a:ext cx="1226820" cy="457200"/>
+          </a:xfrm>
+          <a:prstGeom prst="rect">
+            <a:avLst/>
+          </a:prstGeom>
+          <a:noFill/>
+        </p:spPr>
+        <p:txBody>
+          <a:bodyPr wrap="square">
+            <a:spAutoFit/>
+          </a:bodyPr>
+          <a:lstStyle/>
+          <a:p>
+            <a:pPr algn="ctr">
+              <a:defRPr sz="900" b="1">
+                <a:solidFill>
+                  <a:srgbClr val="002060"/>
+                </a:solidFill>
+                <a:latin typeface="Arial"/>
+              </a:defRPr>
+            </a:pPr>
+            <a:r>
+              <a:t>Rest of World</a:t>
+            </a:r>
+            <a:br/>
+            <a:r>
+              <a:t>$140M</a:t>
+            </a:r>
+          </a:p>
+        </p:txBody>
+      </p:sp>
+      <p:sp>
+        <p:nvSpPr>
+          <p:cNvPr id="41" name="TextBox 40"/>
+          <p:cNvSpPr txBox="1"/>
+          <p:nvPr/>
+        </p:nvSpPr>
+        <p:spPr>
+          <a:xfrm>
+            <a:off x="11475720" y="1280160"/>
+            <a:ext cx="1371600" cy="320040"/>
+          </a:xfrm>
+          <a:prstGeom prst="rect">
+            <a:avLst/>
+          </a:prstGeom>
+          <a:solidFill>
+            <a:srgbClr val="002060"/>
+          </a:solidFill>
+        </p:spPr>
+        <p:txBody>
+          <a:bodyPr wrap="none">
+            <a:spAutoFit/>
+          </a:bodyPr>
+          <a:lstStyle/>
+          <a:p>
+            <a:pPr algn="ctr">
+              <a:defRPr sz="900">
+                <a:solidFill>
+                  <a:srgbClr val="FFFFFF"/>
+                </a:solidFill>
+                <a:latin typeface="Arial"/>
+              </a:defRPr>
+            </a:pPr>
+            <a:r>
+              <a:t>Premium</a:t>
+            </a:r>
+          </a:p>
+        </p:txBody>
+      </p:sp>
+      <p:sp>
+        <p:nvSpPr>
+          <p:cNvPr id="42" name="TextBox 41"/>
+          <p:cNvSpPr txBox="1"/>
+          <p:nvPr/>
+        </p:nvSpPr>
+        <p:spPr>
+          <a:xfrm>
+            <a:off x="11475720" y="1645920"/>
+            <a:ext cx="1371600" cy="320040"/>
+          </a:xfrm>
+          <a:prstGeom prst="rect">
+            <a:avLst/>
+          </a:prstGeom>
+          <a:solidFill>
+            <a:srgbClr val="1F5FA6"/>
+          </a:solidFill>
+        </p:spPr>
+        <p:txBody>
+          <a:bodyPr wrap="none">
+            <a:spAutoFit/>
+          </a:bodyPr>
+          <a:lstStyle/>
+          <a:p>
+            <a:pPr algn="ctr">
+              <a:defRPr sz="900">
+                <a:solidFill>
+                  <a:srgbClr val="FFFFFF"/>
+                </a:solidFill>
+                <a:latin typeface="Arial"/>
+              </a:defRPr>
+            </a:pPr>
+            <a:r>
+              <a:t>Mid-Range</a:t>
+            </a:r>
+          </a:p>
+        </p:txBody>
+      </p:sp>
+      <p:sp>
+        <p:nvSpPr>
+          <p:cNvPr id="43" name="TextBox 42"/>
+          <p:cNvSpPr txBox="1"/>
+          <p:nvPr/>
+        </p:nvSpPr>
+        <p:spPr>
+          <a:xfrm>
+            <a:off x="11475720" y="2011680"/>
+            <a:ext cx="1371600" cy="320040"/>
+          </a:xfrm>
+          <a:prstGeom prst="rect">
+            <a:avLst/>
+          </a:prstGeom>
+          <a:solidFill>
+            <a:srgbClr val="9DC3E6"/>
+          </a:solidFill>
+        </p:spPr>
+        <p:txBody>
+          <a:bodyPr wrap="none">
+            <a:spAutoFit/>
+          </a:bodyPr>
+          <a:lstStyle/>
+          <a:p>
+            <a:pPr algn="ctr">
+              <a:defRPr sz="900">
+                <a:solidFill>
+                  <a:srgbClr val="000000"/>
+                </a:solidFill>
+                <a:latin typeface="Arial"/>
+              </a:defRPr>
+            </a:pPr>
+            <a:r>
+              <a:t>Value</a:t>
+            </a:r>
+          </a:p>
+        </p:txBody>
+      </p:sp>
+      <p:sp>
+        <p:nvSpPr>
+          <p:cNvPr id="44" name="TextBox 43"/>
+          <p:cNvSpPr txBox="1"/>
+          <p:nvPr/>
+        </p:nvSpPr>
+        <p:spPr>
+          <a:xfrm>
+            <a:off x="11475720" y="2377440"/>
+            <a:ext cx="1371600" cy="320040"/>
+          </a:xfrm>
+          <a:prstGeom prst="rect">
+            <a:avLst/>
+          </a:prstGeom>
+          <a:solidFill>
+            <a:srgbClr val="D9D9D9"/>
+          </a:solidFill>
+        </p:spPr>
+        <p:txBody>
+          <a:bodyPr wrap="none">
+            <a:spAutoFit/>
+          </a:bodyPr>
+          <a:lstStyle/>
+          <a:p>
+            <a:pPr algn="ctr">
+              <a:defRPr sz="900">
+                <a:solidFill>
+                  <a:srgbClr val="000000"/>
+                </a:solidFill>
+                <a:latin typeface="Arial"/>
+              </a:defRPr>
+            </a:pPr>
+            <a:r>
+              <a:t>Other</a:t>
+            </a:r>
+          </a:p>
+        </p:txBody>
+      </p:sp>
+      <p:sp>
+        <p:nvSpPr>
+          <p:cNvPr id="45" name="TextBox 44"/>
+          <p:cNvSpPr txBox="1"/>
+          <p:nvPr/>
+        </p:nvSpPr>
+        <p:spPr>
+          <a:xfrm>
+            <a:off x="365760" y="6492240"/>
+            <a:ext cx="10972800" cy="274320"/>
+          </a:xfrm>
+          <a:prstGeom prst="rect">
+            <a:avLst/>
+          </a:prstGeom>
+          <a:noFill/>
+        </p:spPr>
+        <p:txBody>
+          <a:bodyPr wrap="none">
+            <a:spAutoFit/>
+          </a:bodyPr>
+          <a:lstStyle/>
+          <a:p>
+            <a:pPr>
+              <a:defRPr sz="800" i="1">
+                <a:solidFill>
+                  <a:srgbClr val="7F7F7F"/>
+                </a:solidFill>
+                <a:latin typeface="Arial"/>
+              </a:defRPr>
+            </a:pPr>
+            <a:r>
+              <a:t>Source: Market Intelligence Report 2024</a:t>
             </a:r>
           </a:p>
         </p:txBody>

</xml_diff>

<commit_message>
Redesign GBS waterfall slide with hand-drawn dotted connector lines
Slide 1 now draws all bars as shapes instead of a native chart,
enabling the dotted horizontal connector lines between columns
(Benchmark → reductions → Signed-off → Transferred → To be transferred)
exactly matching the original McKinsey design.

https://claude.ai/code/session_01Di57Cqdfup39DVN9Mc9hXr
</commit_message>
<xml_diff>
--- a/McKinsey_Slides.pptx
+++ b/McKinsey_Slides.pptx
@@ -119,725 +119,6 @@
     <c:autoTitleDeleted val="1"/>
     <c:plotArea>
       <c:barChart>
-        <c:barDir val="col"/>
-        <c:grouping val="stacked"/>
-        <c:ser>
-          <c:idx val="0"/>
-          <c:order val="0"/>
-          <c:tx>
-            <c:strRef>
-              <c:f>Sheet1!$B$1</c:f>
-              <c:strCache>
-                <c:ptCount val="1"/>
-                <c:pt idx="0">
-                  <c:v>Spacer</c:v>
-                </c:pt>
-              </c:strCache>
-            </c:strRef>
-          </c:tx>
-          <c:spPr>
-            <a:noFill/>
-            <a:ln>
-              <a:noFill/>
-            </a:ln>
-          </c:spPr>
-          <c:cat>
-            <c:strRef>
-              <c:f>Sheet1!$A$2:$A$8</c:f>
-              <c:strCache>
-                <c:ptCount val="7"/>
-                <c:pt idx="0">
-                  <c:v>Benchmark
-scope</c:v>
-                </c:pt>
-                <c:pt idx="1">
-                  <c:v>Process
-standardization</c:v>
-                </c:pt>
-                <c:pt idx="2">
-                  <c:v>Strategic
-importance</c:v>
-                </c:pt>
-                <c:pt idx="3">
-                  <c:v>System
-limitations</c:v>
-                </c:pt>
-                <c:pt idx="4">
-                  <c:v>Signed-off
-scope</c:v>
-                </c:pt>
-                <c:pt idx="5">
-                  <c:v>Transferred
-to date</c:v>
-                </c:pt>
-                <c:pt idx="6">
-                  <c:v>To be
-transferred</c:v>
-                </c:pt>
-              </c:strCache>
-            </c:strRef>
-          </c:cat>
-          <c:val>
-            <c:numRef>
-              <c:f>Sheet1!$B$2:$B$8</c:f>
-              <c:numCache>
-                <c:formatCode>General</c:formatCode>
-                <c:ptCount val="7"/>
-                <c:pt idx="0">
-                  <c:v>0</c:v>
-                </c:pt>
-                <c:pt idx="1">
-                  <c:v>172</c:v>
-                </c:pt>
-                <c:pt idx="2">
-                  <c:v>151</c:v>
-                </c:pt>
-                <c:pt idx="3">
-                  <c:v>129</c:v>
-                </c:pt>
-                <c:pt idx="4">
-                  <c:v>0</c:v>
-                </c:pt>
-                <c:pt idx="5">
-                  <c:v>0</c:v>
-                </c:pt>
-                <c:pt idx="6">
-                  <c:v>0</c:v>
-                </c:pt>
-              </c:numCache>
-            </c:numRef>
-          </c:val>
-        </c:ser>
-        <c:ser>
-          <c:idx val="1"/>
-          <c:order val="1"/>
-          <c:tx>
-            <c:strRef>
-              <c:f>Sheet1!$C$1</c:f>
-              <c:strCache>
-                <c:ptCount val="1"/>
-                <c:pt idx="0">
-                  <c:v>Scope reduction</c:v>
-                </c:pt>
-              </c:strCache>
-            </c:strRef>
-          </c:tx>
-          <c:spPr>
-            <a:solidFill>
-              <a:srgbClr val="D9D9D9"/>
-            </a:solidFill>
-            <a:ln>
-              <a:solidFill>
-                <a:srgbClr val="D9D9D9"/>
-              </a:solidFill>
-            </a:ln>
-          </c:spPr>
-          <c:dLbls>
-            <c:txPr>
-              <a:bodyPr/>
-              <a:lstStyle/>
-              <a:p>
-                <a:pPr>
-                  <a:defRPr sz="900" b="1">
-                    <a:latin typeface="Arial"/>
-                  </a:defRPr>
-                </a:pPr>
-              </a:p>
-            </c:txPr>
-            <c:showLegendKey val="0"/>
-            <c:showVal val="1"/>
-            <c:showCatName val="0"/>
-            <c:showSerName val="0"/>
-            <c:showPercent val="0"/>
-            <c:showBubbleSize val="0"/>
-            <c:showLeaderLines val="1"/>
-          </c:dLbls>
-          <c:cat>
-            <c:strRef>
-              <c:f>Sheet1!$A$2:$A$8</c:f>
-              <c:strCache>
-                <c:ptCount val="7"/>
-                <c:pt idx="0">
-                  <c:v>Benchmark
-scope</c:v>
-                </c:pt>
-                <c:pt idx="1">
-                  <c:v>Process
-standardization</c:v>
-                </c:pt>
-                <c:pt idx="2">
-                  <c:v>Strategic
-importance</c:v>
-                </c:pt>
-                <c:pt idx="3">
-                  <c:v>System
-limitations</c:v>
-                </c:pt>
-                <c:pt idx="4">
-                  <c:v>Signed-off
-scope</c:v>
-                </c:pt>
-                <c:pt idx="5">
-                  <c:v>Transferred
-to date</c:v>
-                </c:pt>
-                <c:pt idx="6">
-                  <c:v>To be
-transferred</c:v>
-                </c:pt>
-              </c:strCache>
-            </c:strRef>
-          </c:cat>
-          <c:val>
-            <c:numRef>
-              <c:f>Sheet1!$C$2:$C$8</c:f>
-              <c:numCache>
-                <c:formatCode>General</c:formatCode>
-                <c:ptCount val="7"/>
-                <c:pt idx="0">
-                  <c:v>0</c:v>
-                </c:pt>
-                <c:pt idx="1">
-                  <c:v>21</c:v>
-                </c:pt>
-                <c:pt idx="2">
-                  <c:v>21</c:v>
-                </c:pt>
-                <c:pt idx="3">
-                  <c:v>22</c:v>
-                </c:pt>
-                <c:pt idx="4">
-                  <c:v>0</c:v>
-                </c:pt>
-                <c:pt idx="5">
-                  <c:v>0</c:v>
-                </c:pt>
-                <c:pt idx="6">
-                  <c:v>0</c:v>
-                </c:pt>
-              </c:numCache>
-            </c:numRef>
-          </c:val>
-        </c:ser>
-        <c:ser>
-          <c:idx val="2"/>
-          <c:order val="2"/>
-          <c:tx>
-            <c:strRef>
-              <c:f>Sheet1!$D$1</c:f>
-              <c:strCache>
-                <c:ptCount val="1"/>
-                <c:pt idx="0">
-                  <c:v>Accounting</c:v>
-                </c:pt>
-              </c:strCache>
-            </c:strRef>
-          </c:tx>
-          <c:spPr>
-            <a:solidFill>
-              <a:srgbClr val="000000"/>
-            </a:solidFill>
-            <a:ln>
-              <a:solidFill>
-                <a:srgbClr val="000000"/>
-              </a:solidFill>
-            </a:ln>
-          </c:spPr>
-          <c:dLbls>
-            <c:txPr>
-              <a:bodyPr/>
-              <a:lstStyle/>
-              <a:p>
-                <a:pPr>
-                  <a:defRPr sz="900" b="1">
-                    <a:solidFill>
-                      <a:srgbClr val="FFFFFF"/>
-                    </a:solidFill>
-                    <a:latin typeface="Arial"/>
-                  </a:defRPr>
-                </a:pPr>
-              </a:p>
-            </c:txPr>
-            <c:showLegendKey val="0"/>
-            <c:showVal val="1"/>
-            <c:showCatName val="0"/>
-            <c:showSerName val="0"/>
-            <c:showPercent val="0"/>
-            <c:showBubbleSize val="0"/>
-            <c:showLeaderLines val="1"/>
-          </c:dLbls>
-          <c:cat>
-            <c:strRef>
-              <c:f>Sheet1!$A$2:$A$8</c:f>
-              <c:strCache>
-                <c:ptCount val="7"/>
-                <c:pt idx="0">
-                  <c:v>Benchmark
-scope</c:v>
-                </c:pt>
-                <c:pt idx="1">
-                  <c:v>Process
-standardization</c:v>
-                </c:pt>
-                <c:pt idx="2">
-                  <c:v>Strategic
-importance</c:v>
-                </c:pt>
-                <c:pt idx="3">
-                  <c:v>System
-limitations</c:v>
-                </c:pt>
-                <c:pt idx="4">
-                  <c:v>Signed-off
-scope</c:v>
-                </c:pt>
-                <c:pt idx="5">
-                  <c:v>Transferred
-to date</c:v>
-                </c:pt>
-                <c:pt idx="6">
-                  <c:v>To be
-transferred</c:v>
-                </c:pt>
-              </c:strCache>
-            </c:strRef>
-          </c:cat>
-          <c:val>
-            <c:numRef>
-              <c:f>Sheet1!$D$2:$D$8</c:f>
-              <c:numCache>
-                <c:formatCode>General</c:formatCode>
-                <c:ptCount val="7"/>
-                <c:pt idx="0">
-                  <c:v>89</c:v>
-                </c:pt>
-                <c:pt idx="1">
-                  <c:v>0</c:v>
-                </c:pt>
-                <c:pt idx="2">
-                  <c:v>0</c:v>
-                </c:pt>
-                <c:pt idx="3">
-                  <c:v>0</c:v>
-                </c:pt>
-                <c:pt idx="4">
-                  <c:v>66</c:v>
-                </c:pt>
-                <c:pt idx="5">
-                  <c:v>45</c:v>
-                </c:pt>
-                <c:pt idx="6">
-                  <c:v>21</c:v>
-                </c:pt>
-              </c:numCache>
-            </c:numRef>
-          </c:val>
-        </c:ser>
-        <c:ser>
-          <c:idx val="3"/>
-          <c:order val="3"/>
-          <c:tx>
-            <c:strRef>
-              <c:f>Sheet1!$E$1</c:f>
-              <c:strCache>
-                <c:ptCount val="1"/>
-                <c:pt idx="0">
-                  <c:v>Customer Service</c:v>
-                </c:pt>
-              </c:strCache>
-            </c:strRef>
-          </c:tx>
-          <c:spPr>
-            <a:solidFill>
-              <a:srgbClr val="002060"/>
-            </a:solidFill>
-            <a:ln>
-              <a:solidFill>
-                <a:srgbClr val="002060"/>
-              </a:solidFill>
-            </a:ln>
-          </c:spPr>
-          <c:dLbls>
-            <c:txPr>
-              <a:bodyPr/>
-              <a:lstStyle/>
-              <a:p>
-                <a:pPr>
-                  <a:defRPr sz="900" b="1">
-                    <a:solidFill>
-                      <a:srgbClr val="FFFFFF"/>
-                    </a:solidFill>
-                    <a:latin typeface="Arial"/>
-                  </a:defRPr>
-                </a:pPr>
-              </a:p>
-            </c:txPr>
-            <c:showLegendKey val="0"/>
-            <c:showVal val="1"/>
-            <c:showCatName val="0"/>
-            <c:showSerName val="0"/>
-            <c:showPercent val="0"/>
-            <c:showBubbleSize val="0"/>
-            <c:showLeaderLines val="1"/>
-          </c:dLbls>
-          <c:cat>
-            <c:strRef>
-              <c:f>Sheet1!$A$2:$A$8</c:f>
-              <c:strCache>
-                <c:ptCount val="7"/>
-                <c:pt idx="0">
-                  <c:v>Benchmark
-scope</c:v>
-                </c:pt>
-                <c:pt idx="1">
-                  <c:v>Process
-standardization</c:v>
-                </c:pt>
-                <c:pt idx="2">
-                  <c:v>Strategic
-importance</c:v>
-                </c:pt>
-                <c:pt idx="3">
-                  <c:v>System
-limitations</c:v>
-                </c:pt>
-                <c:pt idx="4">
-                  <c:v>Signed-off
-scope</c:v>
-                </c:pt>
-                <c:pt idx="5">
-                  <c:v>Transferred
-to date</c:v>
-                </c:pt>
-                <c:pt idx="6">
-                  <c:v>To be
-transferred</c:v>
-                </c:pt>
-              </c:strCache>
-            </c:strRef>
-          </c:cat>
-          <c:val>
-            <c:numRef>
-              <c:f>Sheet1!$E$2:$E$8</c:f>
-              <c:numCache>
-                <c:formatCode>General</c:formatCode>
-                <c:ptCount val="7"/>
-                <c:pt idx="0">
-                  <c:v>45</c:v>
-                </c:pt>
-                <c:pt idx="1">
-                  <c:v>0</c:v>
-                </c:pt>
-                <c:pt idx="2">
-                  <c:v>0</c:v>
-                </c:pt>
-                <c:pt idx="3">
-                  <c:v>0</c:v>
-                </c:pt>
-                <c:pt idx="4">
-                  <c:v>31</c:v>
-                </c:pt>
-                <c:pt idx="5">
-                  <c:v>23</c:v>
-                </c:pt>
-                <c:pt idx="6">
-                  <c:v>8</c:v>
-                </c:pt>
-              </c:numCache>
-            </c:numRef>
-          </c:val>
-        </c:ser>
-        <c:ser>
-          <c:idx val="4"/>
-          <c:order val="4"/>
-          <c:tx>
-            <c:strRef>
-              <c:f>Sheet1!$F$1</c:f>
-              <c:strCache>
-                <c:ptCount val="1"/>
-                <c:pt idx="0">
-                  <c:v>Procurement</c:v>
-                </c:pt>
-              </c:strCache>
-            </c:strRef>
-          </c:tx>
-          <c:spPr>
-            <a:solidFill>
-              <a:srgbClr val="1F5FA6"/>
-            </a:solidFill>
-            <a:ln>
-              <a:solidFill>
-                <a:srgbClr val="1F5FA6"/>
-              </a:solidFill>
-            </a:ln>
-          </c:spPr>
-          <c:dLbls>
-            <c:txPr>
-              <a:bodyPr/>
-              <a:lstStyle/>
-              <a:p>
-                <a:pPr>
-                  <a:defRPr sz="900" b="1">
-                    <a:solidFill>
-                      <a:srgbClr val="FFFFFF"/>
-                    </a:solidFill>
-                    <a:latin typeface="Arial"/>
-                  </a:defRPr>
-                </a:pPr>
-              </a:p>
-            </c:txPr>
-            <c:showLegendKey val="0"/>
-            <c:showVal val="1"/>
-            <c:showCatName val="0"/>
-            <c:showSerName val="0"/>
-            <c:showPercent val="0"/>
-            <c:showBubbleSize val="0"/>
-            <c:showLeaderLines val="1"/>
-          </c:dLbls>
-          <c:cat>
-            <c:strRef>
-              <c:f>Sheet1!$A$2:$A$8</c:f>
-              <c:strCache>
-                <c:ptCount val="7"/>
-                <c:pt idx="0">
-                  <c:v>Benchmark
-scope</c:v>
-                </c:pt>
-                <c:pt idx="1">
-                  <c:v>Process
-standardization</c:v>
-                </c:pt>
-                <c:pt idx="2">
-                  <c:v>Strategic
-importance</c:v>
-                </c:pt>
-                <c:pt idx="3">
-                  <c:v>System
-limitations</c:v>
-                </c:pt>
-                <c:pt idx="4">
-                  <c:v>Signed-off
-scope</c:v>
-                </c:pt>
-                <c:pt idx="5">
-                  <c:v>Transferred
-to date</c:v>
-                </c:pt>
-                <c:pt idx="6">
-                  <c:v>To be
-transferred</c:v>
-                </c:pt>
-              </c:strCache>
-            </c:strRef>
-          </c:cat>
-          <c:val>
-            <c:numRef>
-              <c:f>Sheet1!$F$2:$F$8</c:f>
-              <c:numCache>
-                <c:formatCode>General</c:formatCode>
-                <c:ptCount val="7"/>
-                <c:pt idx="0">
-                  <c:v>34</c:v>
-                </c:pt>
-                <c:pt idx="1">
-                  <c:v>0</c:v>
-                </c:pt>
-                <c:pt idx="2">
-                  <c:v>0</c:v>
-                </c:pt>
-                <c:pt idx="3">
-                  <c:v>0</c:v>
-                </c:pt>
-                <c:pt idx="4">
-                  <c:v>19</c:v>
-                </c:pt>
-                <c:pt idx="5">
-                  <c:v>19</c:v>
-                </c:pt>
-                <c:pt idx="6">
-                  <c:v>5</c:v>
-                </c:pt>
-              </c:numCache>
-            </c:numRef>
-          </c:val>
-        </c:ser>
-        <c:ser>
-          <c:idx val="5"/>
-          <c:order val="5"/>
-          <c:tx>
-            <c:strRef>
-              <c:f>Sheet1!$G$1</c:f>
-              <c:strCache>
-                <c:ptCount val="1"/>
-                <c:pt idx="0">
-                  <c:v>Sales Support</c:v>
-                </c:pt>
-              </c:strCache>
-            </c:strRef>
-          </c:tx>
-          <c:spPr>
-            <a:solidFill>
-              <a:srgbClr val="9DC3E6"/>
-            </a:solidFill>
-            <a:ln>
-              <a:solidFill>
-                <a:srgbClr val="9DC3E6"/>
-              </a:solidFill>
-            </a:ln>
-          </c:spPr>
-          <c:dLbls>
-            <c:txPr>
-              <a:bodyPr/>
-              <a:lstStyle/>
-              <a:p>
-                <a:pPr>
-                  <a:defRPr sz="900" b="1">
-                    <a:solidFill>
-                      <a:srgbClr val="000000"/>
-                    </a:solidFill>
-                    <a:latin typeface="Arial"/>
-                  </a:defRPr>
-                </a:pPr>
-              </a:p>
-            </c:txPr>
-            <c:showLegendKey val="0"/>
-            <c:showVal val="1"/>
-            <c:showCatName val="0"/>
-            <c:showSerName val="0"/>
-            <c:showPercent val="0"/>
-            <c:showBubbleSize val="0"/>
-            <c:showLeaderLines val="1"/>
-          </c:dLbls>
-          <c:cat>
-            <c:strRef>
-              <c:f>Sheet1!$A$2:$A$8</c:f>
-              <c:strCache>
-                <c:ptCount val="7"/>
-                <c:pt idx="0">
-                  <c:v>Benchmark
-scope</c:v>
-                </c:pt>
-                <c:pt idx="1">
-                  <c:v>Process
-standardization</c:v>
-                </c:pt>
-                <c:pt idx="2">
-                  <c:v>Strategic
-importance</c:v>
-                </c:pt>
-                <c:pt idx="3">
-                  <c:v>System
-limitations</c:v>
-                </c:pt>
-                <c:pt idx="4">
-                  <c:v>Signed-off
-scope</c:v>
-                </c:pt>
-                <c:pt idx="5">
-                  <c:v>Transferred
-to date</c:v>
-                </c:pt>
-                <c:pt idx="6">
-                  <c:v>To be
-transferred</c:v>
-                </c:pt>
-              </c:strCache>
-            </c:strRef>
-          </c:cat>
-          <c:val>
-            <c:numRef>
-              <c:f>Sheet1!$G$2:$G$8</c:f>
-              <c:numCache>
-                <c:formatCode>General</c:formatCode>
-                <c:ptCount val="7"/>
-                <c:pt idx="0">
-                  <c:v>25</c:v>
-                </c:pt>
-                <c:pt idx="1">
-                  <c:v>0</c:v>
-                </c:pt>
-                <c:pt idx="2">
-                  <c:v>0</c:v>
-                </c:pt>
-                <c:pt idx="3">
-                  <c:v>0</c:v>
-                </c:pt>
-                <c:pt idx="4">
-                  <c:v>13</c:v>
-                </c:pt>
-                <c:pt idx="5">
-                  <c:v>8</c:v>
-                </c:pt>
-                <c:pt idx="6">
-                  <c:v>0</c:v>
-                </c:pt>
-              </c:numCache>
-            </c:numRef>
-          </c:val>
-        </c:ser>
-        <c:overlap val="100"/>
-        <c:axId val="-2068027336"/>
-        <c:axId val="-2113994440"/>
-      </c:barChart>
-      <c:catAx>
-        <c:axId val="-2068027336"/>
-        <c:scaling>
-          <c:orientation val="minMax"/>
-        </c:scaling>
-        <c:delete val="0"/>
-        <c:axPos val="b"/>
-        <c:majorTickMark val="out"/>
-        <c:minorTickMark val="none"/>
-        <c:tickLblPos val="nextTo"/>
-        <c:crossAx val="-2113994440"/>
-        <c:crosses val="autoZero"/>
-        <c:auto val="1"/>
-        <c:lblAlgn val="ctr"/>
-        <c:lblOffset val="100"/>
-        <c:noMultiLvlLbl val="0"/>
-      </c:catAx>
-      <c:valAx>
-        <c:axId val="-2113994440"/>
-        <c:scaling/>
-        <c:delete val="0"/>
-        <c:axPos val="l"/>
-        <c:majorGridlines/>
-        <c:majorTickMark val="out"/>
-        <c:minorTickMark val="none"/>
-        <c:tickLblPos val="nextTo"/>
-        <c:crossAx val="-2068027336"/>
-        <c:crosses val="autoZero"/>
-      </c:valAx>
-    </c:plotArea>
-    <c:legend>
-      <c:legendPos val="b"/>
-      <c:overlay val="0"/>
-    </c:legend>
-    <c:dispBlanksAs val="gap"/>
-  </c:chart>
-  <c:txPr>
-    <a:bodyPr/>
-    <a:lstStyle/>
-    <a:p>
-      <a:pPr>
-        <a:defRPr sz="1800"/>
-      </a:pPr>
-      <a:endParaRPr lang="en-US"/>
-    </a:p>
-  </c:txPr>
-  <c:externalData r:id="rId1">
-    <c:autoUpdate val="0"/>
-  </c:externalData>
-</c:chartSpace>
-</file>
-
-<file path=ppt/charts/chart2.xml><?xml version="1.0" encoding="utf-8"?>
-<c:chartSpace xmlns:c="http://schemas.openxmlformats.org/drawingml/2006/chart" xmlns:a="http://schemas.openxmlformats.org/drawingml/2006/main" xmlns:r="http://schemas.openxmlformats.org/officeDocument/2006/relationships">
-  <c:date1904 val="0"/>
-  <c:chart>
-    <c:autoTitleDeleted val="1"/>
-    <c:plotArea>
-      <c:barChart>
         <c:barDir val="bar"/>
         <c:grouping val="stacked"/>
         <c:ser>
@@ -1288,7 +569,7 @@
 </c:chartSpace>
 </file>
 
-<file path=ppt/charts/chart3.xml><?xml version="1.0" encoding="utf-8"?>
+<file path=ppt/charts/chart2.xml><?xml version="1.0" encoding="utf-8"?>
 <c:chartSpace xmlns:c="http://schemas.openxmlformats.org/drawingml/2006/chart" xmlns:a="http://schemas.openxmlformats.org/drawingml/2006/main" xmlns:r="http://schemas.openxmlformats.org/officeDocument/2006/relationships">
   <c:chart>
     <c:autoTitleDeleted val="1"/>
@@ -1584,7 +865,7 @@
 </c:chartSpace>
 </file>
 
-<file path=ppt/charts/chart4.xml><?xml version="1.0" encoding="utf-8"?>
+<file path=ppt/charts/chart3.xml><?xml version="1.0" encoding="utf-8"?>
 <c:chartSpace xmlns:c="http://schemas.openxmlformats.org/drawingml/2006/chart" xmlns:a="http://schemas.openxmlformats.org/drawingml/2006/main" xmlns:r="http://schemas.openxmlformats.org/officeDocument/2006/relationships">
   <c:date1904 val="0"/>
   <c:roundedCorners val="0"/>
@@ -1766,7 +1047,7 @@
 </c:chartSpace>
 </file>
 
-<file path=ppt/charts/chart5.xml><?xml version="1.0" encoding="utf-8"?>
+<file path=ppt/charts/chart4.xml><?xml version="1.0" encoding="utf-8"?>
 <c:chartSpace xmlns:c="http://schemas.openxmlformats.org/drawingml/2006/chart" xmlns:a="http://schemas.openxmlformats.org/drawingml/2006/main" xmlns:r="http://schemas.openxmlformats.org/officeDocument/2006/relationships">
   <c:date1904 val="0"/>
   <c:roundedCorners val="0"/>
@@ -1948,7 +1229,7 @@
 </c:chartSpace>
 </file>
 
-<file path=ppt/charts/chart6.xml><?xml version="1.0" encoding="utf-8"?>
+<file path=ppt/charts/chart5.xml><?xml version="1.0" encoding="utf-8"?>
 <c:chartSpace xmlns:c="http://schemas.openxmlformats.org/drawingml/2006/chart" xmlns:a="http://schemas.openxmlformats.org/drawingml/2006/main" xmlns:r="http://schemas.openxmlformats.org/officeDocument/2006/relationships">
   <c:date1904 val="0"/>
   <c:roundedCorners val="0"/>
@@ -2130,7 +1411,7 @@
 </c:chartSpace>
 </file>
 
-<file path=ppt/charts/chart7.xml><?xml version="1.0" encoding="utf-8"?>
+<file path=ppt/charts/chart6.xml><?xml version="1.0" encoding="utf-8"?>
 <c:chartSpace xmlns:c="http://schemas.openxmlformats.org/drawingml/2006/chart" xmlns:a="http://schemas.openxmlformats.org/drawingml/2006/main" xmlns:r="http://schemas.openxmlformats.org/officeDocument/2006/relationships">
   <c:date1904 val="0"/>
   <c:chart>
@@ -5755,27 +5036,2142 @@
           </a:p>
         </p:txBody>
       </p:sp>
-      <p:graphicFrame>
-        <p:nvGraphicFramePr>
-          <p:cNvPr id="5" name="Chart 4"/>
-          <p:cNvGraphicFramePr>
-            <a:graphicFrameLocks noGrp="1"/>
-          </p:cNvGraphicFramePr>
-          <p:nvPr/>
-        </p:nvGraphicFramePr>
-        <p:xfrm>
-          <a:off x="365760" y="1234440"/>
-          <a:ext cx="11430000" cy="5029200"/>
-        </p:xfrm>
-        <a:graphic>
-          <a:graphicData uri="http://schemas.openxmlformats.org/drawingml/2006/chart">
-            <c:chart xmlns:c="http://schemas.openxmlformats.org/drawingml/2006/chart" r:id="rId2"/>
-          </a:graphicData>
-        </a:graphic>
-      </p:graphicFrame>
+      <p:sp>
+        <p:nvSpPr>
+          <p:cNvPr id="5" name="Rectangle 4"/>
+          <p:cNvSpPr/>
+          <p:nvPr/>
+        </p:nvSpPr>
+        <p:spPr>
+          <a:xfrm>
+            <a:off x="1828800" y="4039569"/>
+            <a:ext cx="1280160" cy="1812590"/>
+          </a:xfrm>
+          <a:prstGeom prst="rect">
+            <a:avLst/>
+          </a:prstGeom>
+          <a:solidFill>
+            <a:srgbClr val="000000"/>
+          </a:solidFill>
+          <a:ln>
+            <a:noFill/>
+          </a:ln>
+        </p:spPr>
+        <p:style>
+          <a:lnRef idx="1">
+            <a:schemeClr val="accent1"/>
+          </a:lnRef>
+          <a:fillRef idx="3">
+            <a:schemeClr val="accent1"/>
+          </a:fillRef>
+          <a:effectRef idx="2">
+            <a:schemeClr val="accent1"/>
+          </a:effectRef>
+          <a:fontRef idx="minor">
+            <a:schemeClr val="lt1"/>
+          </a:fontRef>
+        </p:style>
+        <p:txBody>
+          <a:bodyPr rtlCol="0" anchor="ctr"/>
+          <a:lstStyle/>
+          <a:p>
+            <a:pPr algn="ctr"/>
+          </a:p>
+        </p:txBody>
+      </p:sp>
       <p:sp>
         <p:nvSpPr>
           <p:cNvPr id="6" name="TextBox 5"/>
+          <p:cNvSpPr txBox="1"/>
+          <p:nvPr/>
+        </p:nvSpPr>
+        <p:spPr>
+          <a:xfrm>
+            <a:off x="1828800" y="4184577"/>
+            <a:ext cx="1280160" cy="1522575"/>
+          </a:xfrm>
+          <a:prstGeom prst="rect">
+            <a:avLst/>
+          </a:prstGeom>
+          <a:noFill/>
+        </p:spPr>
+        <p:txBody>
+          <a:bodyPr wrap="none">
+            <a:spAutoFit/>
+          </a:bodyPr>
+          <a:lstStyle/>
+          <a:p>
+            <a:pPr algn="ctr">
+              <a:defRPr sz="1100" b="1">
+                <a:solidFill>
+                  <a:srgbClr val="FFFFFF"/>
+                </a:solidFill>
+                <a:latin typeface="Arial"/>
+              </a:defRPr>
+            </a:pPr>
+            <a:r>
+              <a:t>89</a:t>
+            </a:r>
+          </a:p>
+        </p:txBody>
+      </p:sp>
+      <p:sp>
+        <p:nvSpPr>
+          <p:cNvPr id="7" name="Rectangle 6"/>
+          <p:cNvSpPr/>
+          <p:nvPr/>
+        </p:nvSpPr>
+        <p:spPr>
+          <a:xfrm>
+            <a:off x="1828800" y="3123091"/>
+            <a:ext cx="1280160" cy="916478"/>
+          </a:xfrm>
+          <a:prstGeom prst="rect">
+            <a:avLst/>
+          </a:prstGeom>
+          <a:solidFill>
+            <a:srgbClr val="002060"/>
+          </a:solidFill>
+          <a:ln>
+            <a:noFill/>
+          </a:ln>
+        </p:spPr>
+        <p:style>
+          <a:lnRef idx="1">
+            <a:schemeClr val="accent1"/>
+          </a:lnRef>
+          <a:fillRef idx="3">
+            <a:schemeClr val="accent1"/>
+          </a:fillRef>
+          <a:effectRef idx="2">
+            <a:schemeClr val="accent1"/>
+          </a:effectRef>
+          <a:fontRef idx="minor">
+            <a:schemeClr val="lt1"/>
+          </a:fontRef>
+        </p:style>
+        <p:txBody>
+          <a:bodyPr rtlCol="0" anchor="ctr"/>
+          <a:lstStyle/>
+          <a:p>
+            <a:pPr algn="ctr"/>
+          </a:p>
+        </p:txBody>
+      </p:sp>
+      <p:sp>
+        <p:nvSpPr>
+          <p:cNvPr id="8" name="TextBox 7"/>
+          <p:cNvSpPr txBox="1"/>
+          <p:nvPr/>
+        </p:nvSpPr>
+        <p:spPr>
+          <a:xfrm>
+            <a:off x="1828800" y="3196409"/>
+            <a:ext cx="1280160" cy="769841"/>
+          </a:xfrm>
+          <a:prstGeom prst="rect">
+            <a:avLst/>
+          </a:prstGeom>
+          <a:noFill/>
+        </p:spPr>
+        <p:txBody>
+          <a:bodyPr wrap="none">
+            <a:spAutoFit/>
+          </a:bodyPr>
+          <a:lstStyle/>
+          <a:p>
+            <a:pPr algn="ctr">
+              <a:defRPr sz="1100" b="1">
+                <a:solidFill>
+                  <a:srgbClr val="FFFFFF"/>
+                </a:solidFill>
+                <a:latin typeface="Arial"/>
+              </a:defRPr>
+            </a:pPr>
+            <a:r>
+              <a:t>45</a:t>
+            </a:r>
+          </a:p>
+        </p:txBody>
+      </p:sp>
+      <p:sp>
+        <p:nvSpPr>
+          <p:cNvPr id="9" name="Rectangle 8"/>
+          <p:cNvSpPr/>
+          <p:nvPr/>
+        </p:nvSpPr>
+        <p:spPr>
+          <a:xfrm>
+            <a:off x="1828800" y="2430641"/>
+            <a:ext cx="1280160" cy="692450"/>
+          </a:xfrm>
+          <a:prstGeom prst="rect">
+            <a:avLst/>
+          </a:prstGeom>
+          <a:solidFill>
+            <a:srgbClr val="1F5FA6"/>
+          </a:solidFill>
+          <a:ln>
+            <a:noFill/>
+          </a:ln>
+        </p:spPr>
+        <p:style>
+          <a:lnRef idx="1">
+            <a:schemeClr val="accent1"/>
+          </a:lnRef>
+          <a:fillRef idx="3">
+            <a:schemeClr val="accent1"/>
+          </a:fillRef>
+          <a:effectRef idx="2">
+            <a:schemeClr val="accent1"/>
+          </a:effectRef>
+          <a:fontRef idx="minor">
+            <a:schemeClr val="lt1"/>
+          </a:fontRef>
+        </p:style>
+        <p:txBody>
+          <a:bodyPr rtlCol="0" anchor="ctr"/>
+          <a:lstStyle/>
+          <a:p>
+            <a:pPr algn="ctr"/>
+          </a:p>
+        </p:txBody>
+      </p:sp>
+      <p:sp>
+        <p:nvSpPr>
+          <p:cNvPr id="10" name="TextBox 9"/>
+          <p:cNvSpPr txBox="1"/>
+          <p:nvPr/>
+        </p:nvSpPr>
+        <p:spPr>
+          <a:xfrm>
+            <a:off x="1828800" y="2486037"/>
+            <a:ext cx="1280160" cy="581658"/>
+          </a:xfrm>
+          <a:prstGeom prst="rect">
+            <a:avLst/>
+          </a:prstGeom>
+          <a:noFill/>
+        </p:spPr>
+        <p:txBody>
+          <a:bodyPr wrap="none">
+            <a:spAutoFit/>
+          </a:bodyPr>
+          <a:lstStyle/>
+          <a:p>
+            <a:pPr algn="ctr">
+              <a:defRPr sz="1100" b="1">
+                <a:solidFill>
+                  <a:srgbClr val="FFFFFF"/>
+                </a:solidFill>
+                <a:latin typeface="Arial"/>
+              </a:defRPr>
+            </a:pPr>
+            <a:r>
+              <a:t>34</a:t>
+            </a:r>
+          </a:p>
+        </p:txBody>
+      </p:sp>
+      <p:sp>
+        <p:nvSpPr>
+          <p:cNvPr id="11" name="Rectangle 10"/>
+          <p:cNvSpPr/>
+          <p:nvPr/>
+        </p:nvSpPr>
+        <p:spPr>
+          <a:xfrm>
+            <a:off x="1828800" y="1921486"/>
+            <a:ext cx="1280160" cy="509154"/>
+          </a:xfrm>
+          <a:prstGeom prst="rect">
+            <a:avLst/>
+          </a:prstGeom>
+          <a:solidFill>
+            <a:srgbClr val="9DC3E6"/>
+          </a:solidFill>
+          <a:ln>
+            <a:noFill/>
+          </a:ln>
+        </p:spPr>
+        <p:style>
+          <a:lnRef idx="1">
+            <a:schemeClr val="accent1"/>
+          </a:lnRef>
+          <a:fillRef idx="3">
+            <a:schemeClr val="accent1"/>
+          </a:fillRef>
+          <a:effectRef idx="2">
+            <a:schemeClr val="accent1"/>
+          </a:effectRef>
+          <a:fontRef idx="minor">
+            <a:schemeClr val="lt1"/>
+          </a:fontRef>
+        </p:style>
+        <p:txBody>
+          <a:bodyPr rtlCol="0" anchor="ctr"/>
+          <a:lstStyle/>
+          <a:p>
+            <a:pPr algn="ctr"/>
+          </a:p>
+        </p:txBody>
+      </p:sp>
+      <p:sp>
+        <p:nvSpPr>
+          <p:cNvPr id="12" name="TextBox 11"/>
+          <p:cNvSpPr txBox="1"/>
+          <p:nvPr/>
+        </p:nvSpPr>
+        <p:spPr>
+          <a:xfrm>
+            <a:off x="1828800" y="1962219"/>
+            <a:ext cx="1280160" cy="427689"/>
+          </a:xfrm>
+          <a:prstGeom prst="rect">
+            <a:avLst/>
+          </a:prstGeom>
+          <a:noFill/>
+        </p:spPr>
+        <p:txBody>
+          <a:bodyPr wrap="none">
+            <a:spAutoFit/>
+          </a:bodyPr>
+          <a:lstStyle/>
+          <a:p>
+            <a:pPr algn="ctr">
+              <a:defRPr sz="1100" b="1">
+                <a:solidFill>
+                  <a:srgbClr val="000000"/>
+                </a:solidFill>
+                <a:latin typeface="Arial"/>
+              </a:defRPr>
+            </a:pPr>
+            <a:r>
+              <a:t>25</a:t>
+            </a:r>
+          </a:p>
+        </p:txBody>
+      </p:sp>
+      <p:sp>
+        <p:nvSpPr>
+          <p:cNvPr id="13" name="TextBox 12"/>
+          <p:cNvSpPr txBox="1"/>
+          <p:nvPr/>
+        </p:nvSpPr>
+        <p:spPr>
+          <a:xfrm>
+            <a:off x="1828800" y="1628878"/>
+            <a:ext cx="1280160" cy="274320"/>
+          </a:xfrm>
+          <a:prstGeom prst="rect">
+            <a:avLst/>
+          </a:prstGeom>
+          <a:noFill/>
+        </p:spPr>
+        <p:txBody>
+          <a:bodyPr wrap="none">
+            <a:spAutoFit/>
+          </a:bodyPr>
+          <a:lstStyle/>
+          <a:p>
+            <a:pPr algn="ctr">
+              <a:defRPr sz="1200" b="1">
+                <a:solidFill>
+                  <a:srgbClr val="404040"/>
+                </a:solidFill>
+                <a:latin typeface="Arial"/>
+              </a:defRPr>
+            </a:pPr>
+            <a:r>
+              <a:t>193</a:t>
+            </a:r>
+          </a:p>
+        </p:txBody>
+      </p:sp>
+      <p:sp>
+        <p:nvSpPr>
+          <p:cNvPr id="14" name="Rectangle 13"/>
+          <p:cNvSpPr/>
+          <p:nvPr/>
+        </p:nvSpPr>
+        <p:spPr>
+          <a:xfrm>
+            <a:off x="6455664" y="4507992"/>
+            <a:ext cx="1280160" cy="1344168"/>
+          </a:xfrm>
+          <a:prstGeom prst="rect">
+            <a:avLst/>
+          </a:prstGeom>
+          <a:solidFill>
+            <a:srgbClr val="000000"/>
+          </a:solidFill>
+          <a:ln>
+            <a:noFill/>
+          </a:ln>
+        </p:spPr>
+        <p:style>
+          <a:lnRef idx="1">
+            <a:schemeClr val="accent1"/>
+          </a:lnRef>
+          <a:fillRef idx="3">
+            <a:schemeClr val="accent1"/>
+          </a:fillRef>
+          <a:effectRef idx="2">
+            <a:schemeClr val="accent1"/>
+          </a:effectRef>
+          <a:fontRef idx="minor">
+            <a:schemeClr val="lt1"/>
+          </a:fontRef>
+        </p:style>
+        <p:txBody>
+          <a:bodyPr rtlCol="0" anchor="ctr"/>
+          <a:lstStyle/>
+          <a:p>
+            <a:pPr algn="ctr"/>
+          </a:p>
+        </p:txBody>
+      </p:sp>
+      <p:sp>
+        <p:nvSpPr>
+          <p:cNvPr id="15" name="TextBox 14"/>
+          <p:cNvSpPr txBox="1"/>
+          <p:nvPr/>
+        </p:nvSpPr>
+        <p:spPr>
+          <a:xfrm>
+            <a:off x="6455664" y="4615525"/>
+            <a:ext cx="1280160" cy="1129101"/>
+          </a:xfrm>
+          <a:prstGeom prst="rect">
+            <a:avLst/>
+          </a:prstGeom>
+          <a:noFill/>
+        </p:spPr>
+        <p:txBody>
+          <a:bodyPr wrap="none">
+            <a:spAutoFit/>
+          </a:bodyPr>
+          <a:lstStyle/>
+          <a:p>
+            <a:pPr algn="ctr">
+              <a:defRPr sz="1100" b="1">
+                <a:solidFill>
+                  <a:srgbClr val="FFFFFF"/>
+                </a:solidFill>
+                <a:latin typeface="Arial"/>
+              </a:defRPr>
+            </a:pPr>
+            <a:r>
+              <a:t>66</a:t>
+            </a:r>
+          </a:p>
+        </p:txBody>
+      </p:sp>
+      <p:sp>
+        <p:nvSpPr>
+          <p:cNvPr id="16" name="Rectangle 15"/>
+          <p:cNvSpPr/>
+          <p:nvPr/>
+        </p:nvSpPr>
+        <p:spPr>
+          <a:xfrm>
+            <a:off x="6455664" y="3876640"/>
+            <a:ext cx="1280160" cy="631351"/>
+          </a:xfrm>
+          <a:prstGeom prst="rect">
+            <a:avLst/>
+          </a:prstGeom>
+          <a:solidFill>
+            <a:srgbClr val="002060"/>
+          </a:solidFill>
+          <a:ln>
+            <a:noFill/>
+          </a:ln>
+        </p:spPr>
+        <p:style>
+          <a:lnRef idx="1">
+            <a:schemeClr val="accent1"/>
+          </a:lnRef>
+          <a:fillRef idx="3">
+            <a:schemeClr val="accent1"/>
+          </a:fillRef>
+          <a:effectRef idx="2">
+            <a:schemeClr val="accent1"/>
+          </a:effectRef>
+          <a:fontRef idx="minor">
+            <a:schemeClr val="lt1"/>
+          </a:fontRef>
+        </p:style>
+        <p:txBody>
+          <a:bodyPr rtlCol="0" anchor="ctr"/>
+          <a:lstStyle/>
+          <a:p>
+            <a:pPr algn="ctr"/>
+          </a:p>
+        </p:txBody>
+      </p:sp>
+      <p:sp>
+        <p:nvSpPr>
+          <p:cNvPr id="17" name="TextBox 16"/>
+          <p:cNvSpPr txBox="1"/>
+          <p:nvPr/>
+        </p:nvSpPr>
+        <p:spPr>
+          <a:xfrm>
+            <a:off x="6455664" y="3927148"/>
+            <a:ext cx="1280160" cy="530335"/>
+          </a:xfrm>
+          <a:prstGeom prst="rect">
+            <a:avLst/>
+          </a:prstGeom>
+          <a:noFill/>
+        </p:spPr>
+        <p:txBody>
+          <a:bodyPr wrap="none">
+            <a:spAutoFit/>
+          </a:bodyPr>
+          <a:lstStyle/>
+          <a:p>
+            <a:pPr algn="ctr">
+              <a:defRPr sz="1100" b="1">
+                <a:solidFill>
+                  <a:srgbClr val="FFFFFF"/>
+                </a:solidFill>
+                <a:latin typeface="Arial"/>
+              </a:defRPr>
+            </a:pPr>
+            <a:r>
+              <a:t>31</a:t>
+            </a:r>
+          </a:p>
+        </p:txBody>
+      </p:sp>
+      <p:sp>
+        <p:nvSpPr>
+          <p:cNvPr id="18" name="Rectangle 17"/>
+          <p:cNvSpPr/>
+          <p:nvPr/>
+        </p:nvSpPr>
+        <p:spPr>
+          <a:xfrm>
+            <a:off x="6455664" y="3489682"/>
+            <a:ext cx="1280160" cy="386957"/>
+          </a:xfrm>
+          <a:prstGeom prst="rect">
+            <a:avLst/>
+          </a:prstGeom>
+          <a:solidFill>
+            <a:srgbClr val="1F5FA6"/>
+          </a:solidFill>
+          <a:ln>
+            <a:noFill/>
+          </a:ln>
+        </p:spPr>
+        <p:style>
+          <a:lnRef idx="1">
+            <a:schemeClr val="accent1"/>
+          </a:lnRef>
+          <a:fillRef idx="3">
+            <a:schemeClr val="accent1"/>
+          </a:fillRef>
+          <a:effectRef idx="2">
+            <a:schemeClr val="accent1"/>
+          </a:effectRef>
+          <a:fontRef idx="minor">
+            <a:schemeClr val="lt1"/>
+          </a:fontRef>
+        </p:style>
+        <p:txBody>
+          <a:bodyPr rtlCol="0" anchor="ctr"/>
+          <a:lstStyle/>
+          <a:p>
+            <a:pPr algn="ctr"/>
+          </a:p>
+        </p:txBody>
+      </p:sp>
+      <p:sp>
+        <p:nvSpPr>
+          <p:cNvPr id="19" name="TextBox 18"/>
+          <p:cNvSpPr txBox="1"/>
+          <p:nvPr/>
+        </p:nvSpPr>
+        <p:spPr>
+          <a:xfrm>
+            <a:off x="6455664" y="3520639"/>
+            <a:ext cx="1280160" cy="325044"/>
+          </a:xfrm>
+          <a:prstGeom prst="rect">
+            <a:avLst/>
+          </a:prstGeom>
+          <a:noFill/>
+        </p:spPr>
+        <p:txBody>
+          <a:bodyPr wrap="none">
+            <a:spAutoFit/>
+          </a:bodyPr>
+          <a:lstStyle/>
+          <a:p>
+            <a:pPr algn="ctr">
+              <a:defRPr sz="1100" b="1">
+                <a:solidFill>
+                  <a:srgbClr val="FFFFFF"/>
+                </a:solidFill>
+                <a:latin typeface="Arial"/>
+              </a:defRPr>
+            </a:pPr>
+            <a:r>
+              <a:t>19</a:t>
+            </a:r>
+          </a:p>
+        </p:txBody>
+      </p:sp>
+      <p:sp>
+        <p:nvSpPr>
+          <p:cNvPr id="20" name="Rectangle 19"/>
+          <p:cNvSpPr/>
+          <p:nvPr/>
+        </p:nvSpPr>
+        <p:spPr>
+          <a:xfrm>
+            <a:off x="6455664" y="3224922"/>
+            <a:ext cx="1280160" cy="264760"/>
+          </a:xfrm>
+          <a:prstGeom prst="rect">
+            <a:avLst/>
+          </a:prstGeom>
+          <a:solidFill>
+            <a:srgbClr val="9DC3E6"/>
+          </a:solidFill>
+          <a:ln>
+            <a:noFill/>
+          </a:ln>
+        </p:spPr>
+        <p:style>
+          <a:lnRef idx="1">
+            <a:schemeClr val="accent1"/>
+          </a:lnRef>
+          <a:fillRef idx="3">
+            <a:schemeClr val="accent1"/>
+          </a:fillRef>
+          <a:effectRef idx="2">
+            <a:schemeClr val="accent1"/>
+          </a:effectRef>
+          <a:fontRef idx="minor">
+            <a:schemeClr val="lt1"/>
+          </a:fontRef>
+        </p:style>
+        <p:txBody>
+          <a:bodyPr rtlCol="0" anchor="ctr"/>
+          <a:lstStyle/>
+          <a:p>
+            <a:pPr algn="ctr"/>
+          </a:p>
+        </p:txBody>
+      </p:sp>
+      <p:sp>
+        <p:nvSpPr>
+          <p:cNvPr id="21" name="TextBox 20"/>
+          <p:cNvSpPr txBox="1"/>
+          <p:nvPr/>
+        </p:nvSpPr>
+        <p:spPr>
+          <a:xfrm>
+            <a:off x="6455664" y="3246103"/>
+            <a:ext cx="1280160" cy="222398"/>
+          </a:xfrm>
+          <a:prstGeom prst="rect">
+            <a:avLst/>
+          </a:prstGeom>
+          <a:noFill/>
+        </p:spPr>
+        <p:txBody>
+          <a:bodyPr wrap="none">
+            <a:spAutoFit/>
+          </a:bodyPr>
+          <a:lstStyle/>
+          <a:p>
+            <a:pPr algn="ctr">
+              <a:defRPr sz="1100" b="1">
+                <a:solidFill>
+                  <a:srgbClr val="000000"/>
+                </a:solidFill>
+                <a:latin typeface="Arial"/>
+              </a:defRPr>
+            </a:pPr>
+            <a:r>
+              <a:t>13</a:t>
+            </a:r>
+          </a:p>
+        </p:txBody>
+      </p:sp>
+      <p:sp>
+        <p:nvSpPr>
+          <p:cNvPr id="22" name="TextBox 21"/>
+          <p:cNvSpPr txBox="1"/>
+          <p:nvPr/>
+        </p:nvSpPr>
+        <p:spPr>
+          <a:xfrm>
+            <a:off x="6455664" y="2932314"/>
+            <a:ext cx="1280160" cy="274320"/>
+          </a:xfrm>
+          <a:prstGeom prst="rect">
+            <a:avLst/>
+          </a:prstGeom>
+          <a:noFill/>
+        </p:spPr>
+        <p:txBody>
+          <a:bodyPr wrap="none">
+            <a:spAutoFit/>
+          </a:bodyPr>
+          <a:lstStyle/>
+          <a:p>
+            <a:pPr algn="ctr">
+              <a:defRPr sz="1200" b="1">
+                <a:solidFill>
+                  <a:srgbClr val="404040"/>
+                </a:solidFill>
+                <a:latin typeface="Arial"/>
+              </a:defRPr>
+            </a:pPr>
+            <a:r>
+              <a:t>129</a:t>
+            </a:r>
+          </a:p>
+        </p:txBody>
+      </p:sp>
+      <p:sp>
+        <p:nvSpPr>
+          <p:cNvPr id="23" name="Rectangle 22"/>
+          <p:cNvSpPr/>
+          <p:nvPr/>
+        </p:nvSpPr>
+        <p:spPr>
+          <a:xfrm>
+            <a:off x="8010144" y="4935681"/>
+            <a:ext cx="1280160" cy="916478"/>
+          </a:xfrm>
+          <a:prstGeom prst="rect">
+            <a:avLst/>
+          </a:prstGeom>
+          <a:solidFill>
+            <a:srgbClr val="000000"/>
+          </a:solidFill>
+          <a:ln>
+            <a:noFill/>
+          </a:ln>
+        </p:spPr>
+        <p:style>
+          <a:lnRef idx="1">
+            <a:schemeClr val="accent1"/>
+          </a:lnRef>
+          <a:fillRef idx="3">
+            <a:schemeClr val="accent1"/>
+          </a:fillRef>
+          <a:effectRef idx="2">
+            <a:schemeClr val="accent1"/>
+          </a:effectRef>
+          <a:fontRef idx="minor">
+            <a:schemeClr val="lt1"/>
+          </a:fontRef>
+        </p:style>
+        <p:txBody>
+          <a:bodyPr rtlCol="0" anchor="ctr"/>
+          <a:lstStyle/>
+          <a:p>
+            <a:pPr algn="ctr"/>
+          </a:p>
+        </p:txBody>
+      </p:sp>
+      <p:sp>
+        <p:nvSpPr>
+          <p:cNvPr id="24" name="TextBox 23"/>
+          <p:cNvSpPr txBox="1"/>
+          <p:nvPr/>
+        </p:nvSpPr>
+        <p:spPr>
+          <a:xfrm>
+            <a:off x="8010144" y="5009000"/>
+            <a:ext cx="1280160" cy="769841"/>
+          </a:xfrm>
+          <a:prstGeom prst="rect">
+            <a:avLst/>
+          </a:prstGeom>
+          <a:noFill/>
+        </p:spPr>
+        <p:txBody>
+          <a:bodyPr wrap="none">
+            <a:spAutoFit/>
+          </a:bodyPr>
+          <a:lstStyle/>
+          <a:p>
+            <a:pPr algn="ctr">
+              <a:defRPr sz="1100" b="1">
+                <a:solidFill>
+                  <a:srgbClr val="FFFFFF"/>
+                </a:solidFill>
+                <a:latin typeface="Arial"/>
+              </a:defRPr>
+            </a:pPr>
+            <a:r>
+              <a:t>45</a:t>
+            </a:r>
+          </a:p>
+        </p:txBody>
+      </p:sp>
+      <p:sp>
+        <p:nvSpPr>
+          <p:cNvPr id="25" name="Rectangle 24"/>
+          <p:cNvSpPr/>
+          <p:nvPr/>
+        </p:nvSpPr>
+        <p:spPr>
+          <a:xfrm>
+            <a:off x="8010144" y="4467259"/>
+            <a:ext cx="1280160" cy="468422"/>
+          </a:xfrm>
+          <a:prstGeom prst="rect">
+            <a:avLst/>
+          </a:prstGeom>
+          <a:solidFill>
+            <a:srgbClr val="002060"/>
+          </a:solidFill>
+          <a:ln>
+            <a:noFill/>
+          </a:ln>
+        </p:spPr>
+        <p:style>
+          <a:lnRef idx="1">
+            <a:schemeClr val="accent1"/>
+          </a:lnRef>
+          <a:fillRef idx="3">
+            <a:schemeClr val="accent1"/>
+          </a:fillRef>
+          <a:effectRef idx="2">
+            <a:schemeClr val="accent1"/>
+          </a:effectRef>
+          <a:fontRef idx="minor">
+            <a:schemeClr val="lt1"/>
+          </a:fontRef>
+        </p:style>
+        <p:txBody>
+          <a:bodyPr rtlCol="0" anchor="ctr"/>
+          <a:lstStyle/>
+          <a:p>
+            <a:pPr algn="ctr"/>
+          </a:p>
+        </p:txBody>
+      </p:sp>
+      <p:sp>
+        <p:nvSpPr>
+          <p:cNvPr id="26" name="TextBox 25"/>
+          <p:cNvSpPr txBox="1"/>
+          <p:nvPr/>
+        </p:nvSpPr>
+        <p:spPr>
+          <a:xfrm>
+            <a:off x="8010144" y="4504733"/>
+            <a:ext cx="1280160" cy="393474"/>
+          </a:xfrm>
+          <a:prstGeom prst="rect">
+            <a:avLst/>
+          </a:prstGeom>
+          <a:noFill/>
+        </p:spPr>
+        <p:txBody>
+          <a:bodyPr wrap="none">
+            <a:spAutoFit/>
+          </a:bodyPr>
+          <a:lstStyle/>
+          <a:p>
+            <a:pPr algn="ctr">
+              <a:defRPr sz="1100" b="1">
+                <a:solidFill>
+                  <a:srgbClr val="FFFFFF"/>
+                </a:solidFill>
+                <a:latin typeface="Arial"/>
+              </a:defRPr>
+            </a:pPr>
+            <a:r>
+              <a:t>23</a:t>
+            </a:r>
+          </a:p>
+        </p:txBody>
+      </p:sp>
+      <p:sp>
+        <p:nvSpPr>
+          <p:cNvPr id="27" name="Rectangle 26"/>
+          <p:cNvSpPr/>
+          <p:nvPr/>
+        </p:nvSpPr>
+        <p:spPr>
+          <a:xfrm>
+            <a:off x="8010144" y="4080302"/>
+            <a:ext cx="1280160" cy="386957"/>
+          </a:xfrm>
+          <a:prstGeom prst="rect">
+            <a:avLst/>
+          </a:prstGeom>
+          <a:solidFill>
+            <a:srgbClr val="1F5FA6"/>
+          </a:solidFill>
+          <a:ln>
+            <a:noFill/>
+          </a:ln>
+        </p:spPr>
+        <p:style>
+          <a:lnRef idx="1">
+            <a:schemeClr val="accent1"/>
+          </a:lnRef>
+          <a:fillRef idx="3">
+            <a:schemeClr val="accent1"/>
+          </a:fillRef>
+          <a:effectRef idx="2">
+            <a:schemeClr val="accent1"/>
+          </a:effectRef>
+          <a:fontRef idx="minor">
+            <a:schemeClr val="lt1"/>
+          </a:fontRef>
+        </p:style>
+        <p:txBody>
+          <a:bodyPr rtlCol="0" anchor="ctr"/>
+          <a:lstStyle/>
+          <a:p>
+            <a:pPr algn="ctr"/>
+          </a:p>
+        </p:txBody>
+      </p:sp>
+      <p:sp>
+        <p:nvSpPr>
+          <p:cNvPr id="28" name="TextBox 27"/>
+          <p:cNvSpPr txBox="1"/>
+          <p:nvPr/>
+        </p:nvSpPr>
+        <p:spPr>
+          <a:xfrm>
+            <a:off x="8010144" y="4111258"/>
+            <a:ext cx="1280160" cy="325044"/>
+          </a:xfrm>
+          <a:prstGeom prst="rect">
+            <a:avLst/>
+          </a:prstGeom>
+          <a:noFill/>
+        </p:spPr>
+        <p:txBody>
+          <a:bodyPr wrap="none">
+            <a:spAutoFit/>
+          </a:bodyPr>
+          <a:lstStyle/>
+          <a:p>
+            <a:pPr algn="ctr">
+              <a:defRPr sz="1100" b="1">
+                <a:solidFill>
+                  <a:srgbClr val="FFFFFF"/>
+                </a:solidFill>
+                <a:latin typeface="Arial"/>
+              </a:defRPr>
+            </a:pPr>
+            <a:r>
+              <a:t>19</a:t>
+            </a:r>
+          </a:p>
+        </p:txBody>
+      </p:sp>
+      <p:sp>
+        <p:nvSpPr>
+          <p:cNvPr id="29" name="Rectangle 28"/>
+          <p:cNvSpPr/>
+          <p:nvPr/>
+        </p:nvSpPr>
+        <p:spPr>
+          <a:xfrm>
+            <a:off x="8010144" y="3917372"/>
+            <a:ext cx="1280160" cy="162929"/>
+          </a:xfrm>
+          <a:prstGeom prst="rect">
+            <a:avLst/>
+          </a:prstGeom>
+          <a:solidFill>
+            <a:srgbClr val="9DC3E6"/>
+          </a:solidFill>
+          <a:ln>
+            <a:noFill/>
+          </a:ln>
+        </p:spPr>
+        <p:style>
+          <a:lnRef idx="1">
+            <a:schemeClr val="accent1"/>
+          </a:lnRef>
+          <a:fillRef idx="3">
+            <a:schemeClr val="accent1"/>
+          </a:fillRef>
+          <a:effectRef idx="2">
+            <a:schemeClr val="accent1"/>
+          </a:effectRef>
+          <a:fontRef idx="minor">
+            <a:schemeClr val="lt1"/>
+          </a:fontRef>
+        </p:style>
+        <p:txBody>
+          <a:bodyPr rtlCol="0" anchor="ctr"/>
+          <a:lstStyle/>
+          <a:p>
+            <a:pPr algn="ctr"/>
+          </a:p>
+        </p:txBody>
+      </p:sp>
+      <p:sp>
+        <p:nvSpPr>
+          <p:cNvPr id="30" name="TextBox 29"/>
+          <p:cNvSpPr txBox="1"/>
+          <p:nvPr/>
+        </p:nvSpPr>
+        <p:spPr>
+          <a:xfrm>
+            <a:off x="8010144" y="3624764"/>
+            <a:ext cx="1280160" cy="274320"/>
+          </a:xfrm>
+          <a:prstGeom prst="rect">
+            <a:avLst/>
+          </a:prstGeom>
+          <a:noFill/>
+        </p:spPr>
+        <p:txBody>
+          <a:bodyPr wrap="none">
+            <a:spAutoFit/>
+          </a:bodyPr>
+          <a:lstStyle/>
+          <a:p>
+            <a:pPr algn="ctr">
+              <a:defRPr sz="1200" b="1">
+                <a:solidFill>
+                  <a:srgbClr val="404040"/>
+                </a:solidFill>
+                <a:latin typeface="Arial"/>
+              </a:defRPr>
+            </a:pPr>
+            <a:r>
+              <a:t>95</a:t>
+            </a:r>
+          </a:p>
+        </p:txBody>
+      </p:sp>
+      <p:sp>
+        <p:nvSpPr>
+          <p:cNvPr id="31" name="Rectangle 30"/>
+          <p:cNvSpPr/>
+          <p:nvPr/>
+        </p:nvSpPr>
+        <p:spPr>
+          <a:xfrm>
+            <a:off x="9564624" y="5424470"/>
+            <a:ext cx="1280160" cy="427689"/>
+          </a:xfrm>
+          <a:prstGeom prst="rect">
+            <a:avLst/>
+          </a:prstGeom>
+          <a:solidFill>
+            <a:srgbClr val="000000"/>
+          </a:solidFill>
+          <a:ln>
+            <a:noFill/>
+          </a:ln>
+        </p:spPr>
+        <p:style>
+          <a:lnRef idx="1">
+            <a:schemeClr val="accent1"/>
+          </a:lnRef>
+          <a:fillRef idx="3">
+            <a:schemeClr val="accent1"/>
+          </a:fillRef>
+          <a:effectRef idx="2">
+            <a:schemeClr val="accent1"/>
+          </a:effectRef>
+          <a:fontRef idx="minor">
+            <a:schemeClr val="lt1"/>
+          </a:fontRef>
+        </p:style>
+        <p:txBody>
+          <a:bodyPr rtlCol="0" anchor="ctr"/>
+          <a:lstStyle/>
+          <a:p>
+            <a:pPr algn="ctr"/>
+          </a:p>
+        </p:txBody>
+      </p:sp>
+      <p:sp>
+        <p:nvSpPr>
+          <p:cNvPr id="32" name="TextBox 31"/>
+          <p:cNvSpPr txBox="1"/>
+          <p:nvPr/>
+        </p:nvSpPr>
+        <p:spPr>
+          <a:xfrm>
+            <a:off x="9564624" y="5458685"/>
+            <a:ext cx="1280160" cy="359259"/>
+          </a:xfrm>
+          <a:prstGeom prst="rect">
+            <a:avLst/>
+          </a:prstGeom>
+          <a:noFill/>
+        </p:spPr>
+        <p:txBody>
+          <a:bodyPr wrap="none">
+            <a:spAutoFit/>
+          </a:bodyPr>
+          <a:lstStyle/>
+          <a:p>
+            <a:pPr algn="ctr">
+              <a:defRPr sz="1100" b="1">
+                <a:solidFill>
+                  <a:srgbClr val="FFFFFF"/>
+                </a:solidFill>
+                <a:latin typeface="Arial"/>
+              </a:defRPr>
+            </a:pPr>
+            <a:r>
+              <a:t>21</a:t>
+            </a:r>
+          </a:p>
+        </p:txBody>
+      </p:sp>
+      <p:sp>
+        <p:nvSpPr>
+          <p:cNvPr id="33" name="Rectangle 32"/>
+          <p:cNvSpPr/>
+          <p:nvPr/>
+        </p:nvSpPr>
+        <p:spPr>
+          <a:xfrm>
+            <a:off x="9564624" y="5261540"/>
+            <a:ext cx="1280160" cy="162929"/>
+          </a:xfrm>
+          <a:prstGeom prst="rect">
+            <a:avLst/>
+          </a:prstGeom>
+          <a:solidFill>
+            <a:srgbClr val="002060"/>
+          </a:solidFill>
+          <a:ln>
+            <a:noFill/>
+          </a:ln>
+        </p:spPr>
+        <p:style>
+          <a:lnRef idx="1">
+            <a:schemeClr val="accent1"/>
+          </a:lnRef>
+          <a:fillRef idx="3">
+            <a:schemeClr val="accent1"/>
+          </a:fillRef>
+          <a:effectRef idx="2">
+            <a:schemeClr val="accent1"/>
+          </a:effectRef>
+          <a:fontRef idx="minor">
+            <a:schemeClr val="lt1"/>
+          </a:fontRef>
+        </p:style>
+        <p:txBody>
+          <a:bodyPr rtlCol="0" anchor="ctr"/>
+          <a:lstStyle/>
+          <a:p>
+            <a:pPr algn="ctr"/>
+          </a:p>
+        </p:txBody>
+      </p:sp>
+      <p:sp>
+        <p:nvSpPr>
+          <p:cNvPr id="34" name="Rectangle 33"/>
+          <p:cNvSpPr/>
+          <p:nvPr/>
+        </p:nvSpPr>
+        <p:spPr>
+          <a:xfrm>
+            <a:off x="9564624" y="5159709"/>
+            <a:ext cx="1280160" cy="101830"/>
+          </a:xfrm>
+          <a:prstGeom prst="rect">
+            <a:avLst/>
+          </a:prstGeom>
+          <a:solidFill>
+            <a:srgbClr val="1F5FA6"/>
+          </a:solidFill>
+          <a:ln>
+            <a:noFill/>
+          </a:ln>
+        </p:spPr>
+        <p:style>
+          <a:lnRef idx="1">
+            <a:schemeClr val="accent1"/>
+          </a:lnRef>
+          <a:fillRef idx="3">
+            <a:schemeClr val="accent1"/>
+          </a:fillRef>
+          <a:effectRef idx="2">
+            <a:schemeClr val="accent1"/>
+          </a:effectRef>
+          <a:fontRef idx="minor">
+            <a:schemeClr val="lt1"/>
+          </a:fontRef>
+        </p:style>
+        <p:txBody>
+          <a:bodyPr rtlCol="0" anchor="ctr"/>
+          <a:lstStyle/>
+          <a:p>
+            <a:pPr algn="ctr"/>
+          </a:p>
+        </p:txBody>
+      </p:sp>
+      <p:sp>
+        <p:nvSpPr>
+          <p:cNvPr id="35" name="TextBox 34"/>
+          <p:cNvSpPr txBox="1"/>
+          <p:nvPr/>
+        </p:nvSpPr>
+        <p:spPr>
+          <a:xfrm>
+            <a:off x="9564624" y="4867101"/>
+            <a:ext cx="1280160" cy="274320"/>
+          </a:xfrm>
+          <a:prstGeom prst="rect">
+            <a:avLst/>
+          </a:prstGeom>
+          <a:noFill/>
+        </p:spPr>
+        <p:txBody>
+          <a:bodyPr wrap="none">
+            <a:spAutoFit/>
+          </a:bodyPr>
+          <a:lstStyle/>
+          <a:p>
+            <a:pPr algn="ctr">
+              <a:defRPr sz="1200" b="1">
+                <a:solidFill>
+                  <a:srgbClr val="404040"/>
+                </a:solidFill>
+                <a:latin typeface="Arial"/>
+              </a:defRPr>
+            </a:pPr>
+            <a:r>
+              <a:t>34</a:t>
+            </a:r>
+          </a:p>
+        </p:txBody>
+      </p:sp>
+      <p:sp>
+        <p:nvSpPr>
+          <p:cNvPr id="36" name="Rectangle 35"/>
+          <p:cNvSpPr/>
+          <p:nvPr/>
+        </p:nvSpPr>
+        <p:spPr>
+          <a:xfrm>
+            <a:off x="3383280" y="1921486"/>
+            <a:ext cx="822960" cy="427689"/>
+          </a:xfrm>
+          <a:prstGeom prst="rect">
+            <a:avLst/>
+          </a:prstGeom>
+          <a:solidFill>
+            <a:srgbClr val="D9D9D9"/>
+          </a:solidFill>
+          <a:ln>
+            <a:noFill/>
+          </a:ln>
+        </p:spPr>
+        <p:style>
+          <a:lnRef idx="1">
+            <a:schemeClr val="accent1"/>
+          </a:lnRef>
+          <a:fillRef idx="3">
+            <a:schemeClr val="accent1"/>
+          </a:fillRef>
+          <a:effectRef idx="2">
+            <a:schemeClr val="accent1"/>
+          </a:effectRef>
+          <a:fontRef idx="minor">
+            <a:schemeClr val="lt1"/>
+          </a:fontRef>
+        </p:style>
+        <p:txBody>
+          <a:bodyPr rtlCol="0" anchor="ctr"/>
+          <a:lstStyle/>
+          <a:p>
+            <a:pPr algn="ctr"/>
+          </a:p>
+        </p:txBody>
+      </p:sp>
+      <p:sp>
+        <p:nvSpPr>
+          <p:cNvPr id="37" name="TextBox 36"/>
+          <p:cNvSpPr txBox="1"/>
+          <p:nvPr/>
+        </p:nvSpPr>
+        <p:spPr>
+          <a:xfrm>
+            <a:off x="3383280" y="1955702"/>
+            <a:ext cx="822960" cy="359259"/>
+          </a:xfrm>
+          <a:prstGeom prst="rect">
+            <a:avLst/>
+          </a:prstGeom>
+          <a:noFill/>
+        </p:spPr>
+        <p:txBody>
+          <a:bodyPr wrap="none">
+            <a:spAutoFit/>
+          </a:bodyPr>
+          <a:lstStyle/>
+          <a:p>
+            <a:pPr algn="ctr">
+              <a:defRPr sz="1100" b="1">
+                <a:solidFill>
+                  <a:srgbClr val="7F7F7F"/>
+                </a:solidFill>
+                <a:latin typeface="Arial"/>
+              </a:defRPr>
+            </a:pPr>
+            <a:r>
+              <a:t>21</a:t>
+            </a:r>
+          </a:p>
+        </p:txBody>
+      </p:sp>
+      <p:sp>
+        <p:nvSpPr>
+          <p:cNvPr id="38" name="Rectangle 37"/>
+          <p:cNvSpPr/>
+          <p:nvPr/>
+        </p:nvSpPr>
+        <p:spPr>
+          <a:xfrm>
+            <a:off x="4370832" y="2349176"/>
+            <a:ext cx="822960" cy="427689"/>
+          </a:xfrm>
+          <a:prstGeom prst="rect">
+            <a:avLst/>
+          </a:prstGeom>
+          <a:solidFill>
+            <a:srgbClr val="D9D9D9"/>
+          </a:solidFill>
+          <a:ln>
+            <a:noFill/>
+          </a:ln>
+        </p:spPr>
+        <p:style>
+          <a:lnRef idx="1">
+            <a:schemeClr val="accent1"/>
+          </a:lnRef>
+          <a:fillRef idx="3">
+            <a:schemeClr val="accent1"/>
+          </a:fillRef>
+          <a:effectRef idx="2">
+            <a:schemeClr val="accent1"/>
+          </a:effectRef>
+          <a:fontRef idx="minor">
+            <a:schemeClr val="lt1"/>
+          </a:fontRef>
+        </p:style>
+        <p:txBody>
+          <a:bodyPr rtlCol="0" anchor="ctr"/>
+          <a:lstStyle/>
+          <a:p>
+            <a:pPr algn="ctr"/>
+          </a:p>
+        </p:txBody>
+      </p:sp>
+      <p:sp>
+        <p:nvSpPr>
+          <p:cNvPr id="39" name="TextBox 38"/>
+          <p:cNvSpPr txBox="1"/>
+          <p:nvPr/>
+        </p:nvSpPr>
+        <p:spPr>
+          <a:xfrm>
+            <a:off x="4370832" y="2383391"/>
+            <a:ext cx="822960" cy="359259"/>
+          </a:xfrm>
+          <a:prstGeom prst="rect">
+            <a:avLst/>
+          </a:prstGeom>
+          <a:noFill/>
+        </p:spPr>
+        <p:txBody>
+          <a:bodyPr wrap="none">
+            <a:spAutoFit/>
+          </a:bodyPr>
+          <a:lstStyle/>
+          <a:p>
+            <a:pPr algn="ctr">
+              <a:defRPr sz="1100" b="1">
+                <a:solidFill>
+                  <a:srgbClr val="7F7F7F"/>
+                </a:solidFill>
+                <a:latin typeface="Arial"/>
+              </a:defRPr>
+            </a:pPr>
+            <a:r>
+              <a:t>21</a:t>
+            </a:r>
+          </a:p>
+        </p:txBody>
+      </p:sp>
+      <p:sp>
+        <p:nvSpPr>
+          <p:cNvPr id="40" name="Rectangle 39"/>
+          <p:cNvSpPr/>
+          <p:nvPr/>
+        </p:nvSpPr>
+        <p:spPr>
+          <a:xfrm>
+            <a:off x="5358384" y="2776866"/>
+            <a:ext cx="822960" cy="448056"/>
+          </a:xfrm>
+          <a:prstGeom prst="rect">
+            <a:avLst/>
+          </a:prstGeom>
+          <a:solidFill>
+            <a:srgbClr val="D9D9D9"/>
+          </a:solidFill>
+          <a:ln>
+            <a:noFill/>
+          </a:ln>
+        </p:spPr>
+        <p:style>
+          <a:lnRef idx="1">
+            <a:schemeClr val="accent1"/>
+          </a:lnRef>
+          <a:fillRef idx="3">
+            <a:schemeClr val="accent1"/>
+          </a:fillRef>
+          <a:effectRef idx="2">
+            <a:schemeClr val="accent1"/>
+          </a:effectRef>
+          <a:fontRef idx="minor">
+            <a:schemeClr val="lt1"/>
+          </a:fontRef>
+        </p:style>
+        <p:txBody>
+          <a:bodyPr rtlCol="0" anchor="ctr"/>
+          <a:lstStyle/>
+          <a:p>
+            <a:pPr algn="ctr"/>
+          </a:p>
+        </p:txBody>
+      </p:sp>
+      <p:sp>
+        <p:nvSpPr>
+          <p:cNvPr id="41" name="TextBox 40"/>
+          <p:cNvSpPr txBox="1"/>
+          <p:nvPr/>
+        </p:nvSpPr>
+        <p:spPr>
+          <a:xfrm>
+            <a:off x="5358384" y="2812711"/>
+            <a:ext cx="822960" cy="376367"/>
+          </a:xfrm>
+          <a:prstGeom prst="rect">
+            <a:avLst/>
+          </a:prstGeom>
+          <a:noFill/>
+        </p:spPr>
+        <p:txBody>
+          <a:bodyPr wrap="none">
+            <a:spAutoFit/>
+          </a:bodyPr>
+          <a:lstStyle/>
+          <a:p>
+            <a:pPr algn="ctr">
+              <a:defRPr sz="1100" b="1">
+                <a:solidFill>
+                  <a:srgbClr val="7F7F7F"/>
+                </a:solidFill>
+                <a:latin typeface="Arial"/>
+              </a:defRPr>
+            </a:pPr>
+            <a:r>
+              <a:t>22</a:t>
+            </a:r>
+          </a:p>
+        </p:txBody>
+      </p:sp>
+      <p:cxnSp>
+        <p:nvCxnSpPr>
+          <p:cNvPr id="42" name="Connector 41"/>
+          <p:cNvCxnSpPr/>
+          <p:nvPr/>
+        </p:nvCxnSpPr>
+        <p:spPr>
+          <a:xfrm>
+            <a:off x="1737360" y="5852160"/>
+            <a:ext cx="9244584" cy="0"/>
+          </a:xfrm>
+          <a:prstGeom prst="line">
+            <a:avLst/>
+          </a:prstGeom>
+          <a:ln w="12700">
+            <a:solidFill>
+              <a:srgbClr val="7F7F7F"/>
+            </a:solidFill>
+          </a:ln>
+        </p:spPr>
+        <p:style>
+          <a:lnRef idx="2">
+            <a:schemeClr val="accent1"/>
+          </a:lnRef>
+          <a:fillRef idx="0">
+            <a:schemeClr val="accent1"/>
+          </a:fillRef>
+          <a:effectRef idx="1">
+            <a:schemeClr val="accent1"/>
+          </a:effectRef>
+          <a:fontRef idx="minor">
+            <a:schemeClr val="tx1"/>
+          </a:fontRef>
+        </p:style>
+      </p:cxnSp>
+      <p:sp>
+        <p:nvSpPr>
+          <p:cNvPr id="43" name="TextBox 42"/>
+          <p:cNvSpPr txBox="1"/>
+          <p:nvPr/>
+        </p:nvSpPr>
+        <p:spPr>
+          <a:xfrm>
+            <a:off x="1755648" y="5943600"/>
+            <a:ext cx="1426464" cy="502920"/>
+          </a:xfrm>
+          <a:prstGeom prst="rect">
+            <a:avLst/>
+          </a:prstGeom>
+          <a:noFill/>
+        </p:spPr>
+        <p:txBody>
+          <a:bodyPr wrap="square">
+            <a:spAutoFit/>
+          </a:bodyPr>
+          <a:lstStyle/>
+          <a:p>
+            <a:pPr algn="ctr">
+              <a:defRPr sz="900" b="0">
+                <a:solidFill>
+                  <a:srgbClr val="000000"/>
+                </a:solidFill>
+                <a:latin typeface="Arial"/>
+              </a:defRPr>
+            </a:pPr>
+            <a:r>
+              <a:t>Benchmark</a:t>
+            </a:r>
+            <a:br/>
+            <a:r>
+              <a:t>scope</a:t>
+            </a:r>
+          </a:p>
+        </p:txBody>
+      </p:sp>
+      <p:sp>
+        <p:nvSpPr>
+          <p:cNvPr id="44" name="TextBox 43"/>
+          <p:cNvSpPr txBox="1"/>
+          <p:nvPr/>
+        </p:nvSpPr>
+        <p:spPr>
+          <a:xfrm>
+            <a:off x="3310128" y="5943600"/>
+            <a:ext cx="969264" cy="502920"/>
+          </a:xfrm>
+          <a:prstGeom prst="rect">
+            <a:avLst/>
+          </a:prstGeom>
+          <a:noFill/>
+        </p:spPr>
+        <p:txBody>
+          <a:bodyPr wrap="square">
+            <a:spAutoFit/>
+          </a:bodyPr>
+          <a:lstStyle/>
+          <a:p>
+            <a:pPr algn="ctr">
+              <a:defRPr sz="900" b="0">
+                <a:solidFill>
+                  <a:srgbClr val="000000"/>
+                </a:solidFill>
+                <a:latin typeface="Arial"/>
+              </a:defRPr>
+            </a:pPr>
+            <a:r>
+              <a:t>Process</a:t>
+            </a:r>
+            <a:br/>
+            <a:r>
+              <a:t>standardization</a:t>
+            </a:r>
+          </a:p>
+        </p:txBody>
+      </p:sp>
+      <p:sp>
+        <p:nvSpPr>
+          <p:cNvPr id="45" name="TextBox 44"/>
+          <p:cNvSpPr txBox="1"/>
+          <p:nvPr/>
+        </p:nvSpPr>
+        <p:spPr>
+          <a:xfrm>
+            <a:off x="4297680" y="5943600"/>
+            <a:ext cx="969264" cy="502920"/>
+          </a:xfrm>
+          <a:prstGeom prst="rect">
+            <a:avLst/>
+          </a:prstGeom>
+          <a:noFill/>
+        </p:spPr>
+        <p:txBody>
+          <a:bodyPr wrap="square">
+            <a:spAutoFit/>
+          </a:bodyPr>
+          <a:lstStyle/>
+          <a:p>
+            <a:pPr algn="ctr">
+              <a:defRPr sz="900" b="0">
+                <a:solidFill>
+                  <a:srgbClr val="000000"/>
+                </a:solidFill>
+                <a:latin typeface="Arial"/>
+              </a:defRPr>
+            </a:pPr>
+            <a:r>
+              <a:t>Strategic</a:t>
+            </a:r>
+            <a:br/>
+            <a:r>
+              <a:t>importance</a:t>
+            </a:r>
+          </a:p>
+        </p:txBody>
+      </p:sp>
+      <p:sp>
+        <p:nvSpPr>
+          <p:cNvPr id="46" name="TextBox 45"/>
+          <p:cNvSpPr txBox="1"/>
+          <p:nvPr/>
+        </p:nvSpPr>
+        <p:spPr>
+          <a:xfrm>
+            <a:off x="5285232" y="5943600"/>
+            <a:ext cx="969264" cy="502920"/>
+          </a:xfrm>
+          <a:prstGeom prst="rect">
+            <a:avLst/>
+          </a:prstGeom>
+          <a:noFill/>
+        </p:spPr>
+        <p:txBody>
+          <a:bodyPr wrap="square">
+            <a:spAutoFit/>
+          </a:bodyPr>
+          <a:lstStyle/>
+          <a:p>
+            <a:pPr algn="ctr">
+              <a:defRPr sz="900" b="0">
+                <a:solidFill>
+                  <a:srgbClr val="000000"/>
+                </a:solidFill>
+                <a:latin typeface="Arial"/>
+              </a:defRPr>
+            </a:pPr>
+            <a:r>
+              <a:t>System</a:t>
+            </a:r>
+            <a:br/>
+            <a:r>
+              <a:t>limitations</a:t>
+            </a:r>
+          </a:p>
+        </p:txBody>
+      </p:sp>
+      <p:sp>
+        <p:nvSpPr>
+          <p:cNvPr id="47" name="TextBox 46"/>
+          <p:cNvSpPr txBox="1"/>
+          <p:nvPr/>
+        </p:nvSpPr>
+        <p:spPr>
+          <a:xfrm>
+            <a:off x="6382512" y="5943600"/>
+            <a:ext cx="1426464" cy="502920"/>
+          </a:xfrm>
+          <a:prstGeom prst="rect">
+            <a:avLst/>
+          </a:prstGeom>
+          <a:noFill/>
+        </p:spPr>
+        <p:txBody>
+          <a:bodyPr wrap="square">
+            <a:spAutoFit/>
+          </a:bodyPr>
+          <a:lstStyle/>
+          <a:p>
+            <a:pPr algn="ctr">
+              <a:defRPr sz="900" b="0">
+                <a:solidFill>
+                  <a:srgbClr val="000000"/>
+                </a:solidFill>
+                <a:latin typeface="Arial"/>
+              </a:defRPr>
+            </a:pPr>
+            <a:r>
+              <a:t>Signed-off</a:t>
+            </a:r>
+            <a:br/>
+            <a:r>
+              <a:t>scope</a:t>
+            </a:r>
+          </a:p>
+        </p:txBody>
+      </p:sp>
+      <p:sp>
+        <p:nvSpPr>
+          <p:cNvPr id="48" name="TextBox 47"/>
+          <p:cNvSpPr txBox="1"/>
+          <p:nvPr/>
+        </p:nvSpPr>
+        <p:spPr>
+          <a:xfrm>
+            <a:off x="7936992" y="5943600"/>
+            <a:ext cx="1426464" cy="502920"/>
+          </a:xfrm>
+          <a:prstGeom prst="rect">
+            <a:avLst/>
+          </a:prstGeom>
+          <a:noFill/>
+        </p:spPr>
+        <p:txBody>
+          <a:bodyPr wrap="square">
+            <a:spAutoFit/>
+          </a:bodyPr>
+          <a:lstStyle/>
+          <a:p>
+            <a:pPr algn="ctr">
+              <a:defRPr sz="900" b="0">
+                <a:solidFill>
+                  <a:srgbClr val="000000"/>
+                </a:solidFill>
+                <a:latin typeface="Arial"/>
+              </a:defRPr>
+            </a:pPr>
+            <a:r>
+              <a:t>Transferred</a:t>
+            </a:r>
+            <a:br/>
+            <a:r>
+              <a:t>to date</a:t>
+            </a:r>
+          </a:p>
+        </p:txBody>
+      </p:sp>
+      <p:sp>
+        <p:nvSpPr>
+          <p:cNvPr id="49" name="TextBox 48"/>
+          <p:cNvSpPr txBox="1"/>
+          <p:nvPr/>
+        </p:nvSpPr>
+        <p:spPr>
+          <a:xfrm>
+            <a:off x="9491472" y="5943600"/>
+            <a:ext cx="1426464" cy="502920"/>
+          </a:xfrm>
+          <a:prstGeom prst="rect">
+            <a:avLst/>
+          </a:prstGeom>
+          <a:noFill/>
+        </p:spPr>
+        <p:txBody>
+          <a:bodyPr wrap="square">
+            <a:spAutoFit/>
+          </a:bodyPr>
+          <a:lstStyle/>
+          <a:p>
+            <a:pPr algn="ctr">
+              <a:defRPr sz="900" b="1">
+                <a:solidFill>
+                  <a:srgbClr val="000000"/>
+                </a:solidFill>
+                <a:latin typeface="Arial"/>
+              </a:defRPr>
+            </a:pPr>
+            <a:r>
+              <a:t>To be</a:t>
+            </a:r>
+            <a:br/>
+            <a:r>
+              <a:t>transferred</a:t>
+            </a:r>
+          </a:p>
+        </p:txBody>
+      </p:sp>
+      <p:sp>
+        <p:nvSpPr>
+          <p:cNvPr id="50" name="TextBox 49"/>
+          <p:cNvSpPr txBox="1"/>
+          <p:nvPr/>
+        </p:nvSpPr>
+        <p:spPr>
+          <a:xfrm>
+            <a:off x="457200" y="4744696"/>
+            <a:ext cx="1325880" cy="402336"/>
+          </a:xfrm>
+          <a:prstGeom prst="rect">
+            <a:avLst/>
+          </a:prstGeom>
+          <a:noFill/>
+        </p:spPr>
+        <p:txBody>
+          <a:bodyPr wrap="square">
+            <a:spAutoFit/>
+          </a:bodyPr>
+          <a:lstStyle/>
+          <a:p>
+            <a:pPr algn="r">
+              <a:defRPr sz="900">
+                <a:solidFill>
+                  <a:srgbClr val="404040"/>
+                </a:solidFill>
+                <a:latin typeface="Arial"/>
+              </a:defRPr>
+            </a:pPr>
+            <a:r>
+              <a:t>Accounting</a:t>
+            </a:r>
+          </a:p>
+        </p:txBody>
+      </p:sp>
+      <p:sp>
+        <p:nvSpPr>
+          <p:cNvPr id="51" name="TextBox 50"/>
+          <p:cNvSpPr txBox="1"/>
+          <p:nvPr/>
+        </p:nvSpPr>
+        <p:spPr>
+          <a:xfrm>
+            <a:off x="457200" y="3380162"/>
+            <a:ext cx="1325880" cy="402336"/>
+          </a:xfrm>
+          <a:prstGeom prst="rect">
+            <a:avLst/>
+          </a:prstGeom>
+          <a:noFill/>
+        </p:spPr>
+        <p:txBody>
+          <a:bodyPr wrap="square">
+            <a:spAutoFit/>
+          </a:bodyPr>
+          <a:lstStyle/>
+          <a:p>
+            <a:pPr algn="r">
+              <a:defRPr sz="900">
+                <a:solidFill>
+                  <a:srgbClr val="404040"/>
+                </a:solidFill>
+                <a:latin typeface="Arial"/>
+              </a:defRPr>
+            </a:pPr>
+            <a:r>
+              <a:t>Customer Service</a:t>
+            </a:r>
+          </a:p>
+        </p:txBody>
+      </p:sp>
+      <p:sp>
+        <p:nvSpPr>
+          <p:cNvPr id="52" name="TextBox 51"/>
+          <p:cNvSpPr txBox="1"/>
+          <p:nvPr/>
+        </p:nvSpPr>
+        <p:spPr>
+          <a:xfrm>
+            <a:off x="457200" y="2575698"/>
+            <a:ext cx="1325880" cy="402336"/>
+          </a:xfrm>
+          <a:prstGeom prst="rect">
+            <a:avLst/>
+          </a:prstGeom>
+          <a:noFill/>
+        </p:spPr>
+        <p:txBody>
+          <a:bodyPr wrap="square">
+            <a:spAutoFit/>
+          </a:bodyPr>
+          <a:lstStyle/>
+          <a:p>
+            <a:pPr algn="r">
+              <a:defRPr sz="900">
+                <a:solidFill>
+                  <a:srgbClr val="404040"/>
+                </a:solidFill>
+                <a:latin typeface="Arial"/>
+              </a:defRPr>
+            </a:pPr>
+            <a:r>
+              <a:t>Procurement</a:t>
+            </a:r>
+          </a:p>
+        </p:txBody>
+      </p:sp>
+      <p:sp>
+        <p:nvSpPr>
+          <p:cNvPr id="53" name="TextBox 52"/>
+          <p:cNvSpPr txBox="1"/>
+          <p:nvPr/>
+        </p:nvSpPr>
+        <p:spPr>
+          <a:xfrm>
+            <a:off x="457200" y="1974896"/>
+            <a:ext cx="1325880" cy="402336"/>
+          </a:xfrm>
+          <a:prstGeom prst="rect">
+            <a:avLst/>
+          </a:prstGeom>
+          <a:noFill/>
+        </p:spPr>
+        <p:txBody>
+          <a:bodyPr wrap="square">
+            <a:spAutoFit/>
+          </a:bodyPr>
+          <a:lstStyle/>
+          <a:p>
+            <a:pPr algn="r">
+              <a:defRPr sz="900">
+                <a:solidFill>
+                  <a:srgbClr val="404040"/>
+                </a:solidFill>
+                <a:latin typeface="Arial"/>
+              </a:defRPr>
+            </a:pPr>
+            <a:r>
+              <a:t>Sales Support</a:t>
+            </a:r>
+          </a:p>
+        </p:txBody>
+      </p:sp>
+      <p:cxnSp>
+        <p:nvCxnSpPr>
+          <p:cNvPr id="54" name="Connector 53"/>
+          <p:cNvCxnSpPr/>
+          <p:nvPr/>
+        </p:nvCxnSpPr>
+        <p:spPr>
+          <a:xfrm>
+            <a:off x="3108960" y="1921486.909090909"/>
+            <a:ext cx="274320" cy="0.0"/>
+          </a:xfrm>
+          <a:prstGeom prst="line">
+            <a:avLst/>
+          </a:prstGeom>
+          <a:ln w="9525">
+            <a:solidFill>
+              <a:srgbClr val="7F7F7F"/>
+            </a:solidFill>
+            <a:prstDash val="dot"/>
+          </a:ln>
+        </p:spPr>
+        <p:style>
+          <a:lnRef idx="2">
+            <a:schemeClr val="accent1"/>
+          </a:lnRef>
+          <a:fillRef idx="0">
+            <a:schemeClr val="accent1"/>
+          </a:fillRef>
+          <a:effectRef idx="1">
+            <a:schemeClr val="accent1"/>
+          </a:effectRef>
+          <a:fontRef idx="minor">
+            <a:schemeClr val="tx1"/>
+          </a:fontRef>
+        </p:style>
+      </p:cxnSp>
+      <p:cxnSp>
+        <p:nvCxnSpPr>
+          <p:cNvPr id="55" name="Connector 54"/>
+          <p:cNvCxnSpPr/>
+          <p:nvPr/>
+        </p:nvCxnSpPr>
+        <p:spPr>
+          <a:xfrm>
+            <a:off x="4206240" y="2349176.727272727"/>
+            <a:ext cx="164592" cy="0.0"/>
+          </a:xfrm>
+          <a:prstGeom prst="line">
+            <a:avLst/>
+          </a:prstGeom>
+          <a:ln w="9525">
+            <a:solidFill>
+              <a:srgbClr val="7F7F7F"/>
+            </a:solidFill>
+            <a:prstDash val="dot"/>
+          </a:ln>
+        </p:spPr>
+        <p:style>
+          <a:lnRef idx="2">
+            <a:schemeClr val="accent1"/>
+          </a:lnRef>
+          <a:fillRef idx="0">
+            <a:schemeClr val="accent1"/>
+          </a:fillRef>
+          <a:effectRef idx="1">
+            <a:schemeClr val="accent1"/>
+          </a:effectRef>
+          <a:fontRef idx="minor">
+            <a:schemeClr val="tx1"/>
+          </a:fontRef>
+        </p:style>
+      </p:cxnSp>
+      <p:cxnSp>
+        <p:nvCxnSpPr>
+          <p:cNvPr id="56" name="Connector 55"/>
+          <p:cNvCxnSpPr/>
+          <p:nvPr/>
+        </p:nvCxnSpPr>
+        <p:spPr>
+          <a:xfrm>
+            <a:off x="5193792" y="2776866.5454545454"/>
+            <a:ext cx="164592" cy="0.0"/>
+          </a:xfrm>
+          <a:prstGeom prst="line">
+            <a:avLst/>
+          </a:prstGeom>
+          <a:ln w="9525">
+            <a:solidFill>
+              <a:srgbClr val="7F7F7F"/>
+            </a:solidFill>
+            <a:prstDash val="dot"/>
+          </a:ln>
+        </p:spPr>
+        <p:style>
+          <a:lnRef idx="2">
+            <a:schemeClr val="accent1"/>
+          </a:lnRef>
+          <a:fillRef idx="0">
+            <a:schemeClr val="accent1"/>
+          </a:fillRef>
+          <a:effectRef idx="1">
+            <a:schemeClr val="accent1"/>
+          </a:effectRef>
+          <a:fontRef idx="minor">
+            <a:schemeClr val="tx1"/>
+          </a:fontRef>
+        </p:style>
+      </p:cxnSp>
+      <p:cxnSp>
+        <p:nvCxnSpPr>
+          <p:cNvPr id="57" name="Connector 56"/>
+          <p:cNvCxnSpPr/>
+          <p:nvPr/>
+        </p:nvCxnSpPr>
+        <p:spPr>
+          <a:xfrm>
+            <a:off x="6181344" y="3224922.545454546"/>
+            <a:ext cx="274320" cy="0.0"/>
+          </a:xfrm>
+          <a:prstGeom prst="line">
+            <a:avLst/>
+          </a:prstGeom>
+          <a:ln w="9525">
+            <a:solidFill>
+              <a:srgbClr val="7F7F7F"/>
+            </a:solidFill>
+            <a:prstDash val="dot"/>
+          </a:ln>
+        </p:spPr>
+        <p:style>
+          <a:lnRef idx="2">
+            <a:schemeClr val="accent1"/>
+          </a:lnRef>
+          <a:fillRef idx="0">
+            <a:schemeClr val="accent1"/>
+          </a:fillRef>
+          <a:effectRef idx="1">
+            <a:schemeClr val="accent1"/>
+          </a:effectRef>
+          <a:fontRef idx="minor">
+            <a:schemeClr val="tx1"/>
+          </a:fontRef>
+        </p:style>
+      </p:cxnSp>
+      <p:cxnSp>
+        <p:nvCxnSpPr>
+          <p:cNvPr id="58" name="Connector 57"/>
+          <p:cNvCxnSpPr/>
+          <p:nvPr/>
+        </p:nvCxnSpPr>
+        <p:spPr>
+          <a:xfrm>
+            <a:off x="7735824" y="3917372.727272727"/>
+            <a:ext cx="274320" cy="0.0"/>
+          </a:xfrm>
+          <a:prstGeom prst="line">
+            <a:avLst/>
+          </a:prstGeom>
+          <a:ln w="9525">
+            <a:solidFill>
+              <a:srgbClr val="7F7F7F"/>
+            </a:solidFill>
+            <a:prstDash val="dot"/>
+          </a:ln>
+        </p:spPr>
+        <p:style>
+          <a:lnRef idx="2">
+            <a:schemeClr val="accent1"/>
+          </a:lnRef>
+          <a:fillRef idx="0">
+            <a:schemeClr val="accent1"/>
+          </a:fillRef>
+          <a:effectRef idx="1">
+            <a:schemeClr val="accent1"/>
+          </a:effectRef>
+          <a:fontRef idx="minor">
+            <a:schemeClr val="tx1"/>
+          </a:fontRef>
+        </p:style>
+      </p:cxnSp>
+      <p:cxnSp>
+        <p:nvCxnSpPr>
+          <p:cNvPr id="59" name="Connector 58"/>
+          <p:cNvCxnSpPr/>
+          <p:nvPr/>
+        </p:nvCxnSpPr>
+        <p:spPr>
+          <a:xfrm>
+            <a:off x="9290304" y="5159709.818181818"/>
+            <a:ext cx="274320" cy="0.0"/>
+          </a:xfrm>
+          <a:prstGeom prst="line">
+            <a:avLst/>
+          </a:prstGeom>
+          <a:ln w="9525">
+            <a:solidFill>
+              <a:srgbClr val="7F7F7F"/>
+            </a:solidFill>
+            <a:prstDash val="dot"/>
+          </a:ln>
+        </p:spPr>
+        <p:style>
+          <a:lnRef idx="2">
+            <a:schemeClr val="accent1"/>
+          </a:lnRef>
+          <a:fillRef idx="0">
+            <a:schemeClr val="accent1"/>
+          </a:fillRef>
+          <a:effectRef idx="1">
+            <a:schemeClr val="accent1"/>
+          </a:effectRef>
+          <a:fontRef idx="minor">
+            <a:schemeClr val="tx1"/>
+          </a:fontRef>
+        </p:style>
+      </p:cxnSp>
+      <p:sp>
+        <p:nvSpPr>
+          <p:cNvPr id="60" name="TextBox 59"/>
           <p:cNvSpPr txBox="1"/>
           <p:nvPr/>
         </p:nvSpPr>

</xml_diff>

<commit_message>
Fix float EMU coordinates causing PPTX to fail opening on Keynote/iPad
vy() and textbox positioning were producing float EMU values
(e.g. y="1921486.909090909") which are invalid per OOXML spec.
Keynote on iOS enforces integer-only EMU values strictly.
Wrapped vy() with int() and all derived coordinates likewise.

https://claude.ai/code/session_01Di57Cqdfup39DVN9Mc9hXr
</commit_message>
<xml_diff>
--- a/McKinsey_Slides.pptx
+++ b/McKinsey_Slides.pptx
@@ -5045,7 +5045,7 @@
         <p:spPr>
           <a:xfrm>
             <a:off x="1828800" y="4039569"/>
-            <a:ext cx="1280160" cy="1812590"/>
+            <a:ext cx="1280160" cy="1812591"/>
           </a:xfrm>
           <a:prstGeom prst="rect">
             <a:avLst/>
@@ -5087,8 +5087,8 @@
         </p:nvSpPr>
         <p:spPr>
           <a:xfrm>
-            <a:off x="1828800" y="4184577"/>
-            <a:ext cx="1280160" cy="1522575"/>
+            <a:off x="1828800" y="4184576"/>
+            <a:ext cx="1280160" cy="1522576"/>
           </a:xfrm>
           <a:prstGeom prst="rect">
             <a:avLst/>
@@ -5282,7 +5282,7 @@
         <p:spPr>
           <a:xfrm>
             <a:off x="1828800" y="1921486"/>
-            <a:ext cx="1280160" cy="509154"/>
+            <a:ext cx="1280160" cy="509155"/>
           </a:xfrm>
           <a:prstGeom prst="rect">
             <a:avLst/>
@@ -5324,8 +5324,8 @@
         </p:nvSpPr>
         <p:spPr>
           <a:xfrm>
-            <a:off x="1828800" y="1962219"/>
-            <a:ext cx="1280160" cy="427689"/>
+            <a:off x="1828800" y="1962218"/>
+            <a:ext cx="1280160" cy="427690"/>
           </a:xfrm>
           <a:prstGeom prst="rect">
             <a:avLst/>
@@ -5476,7 +5476,7 @@
         <p:spPr>
           <a:xfrm>
             <a:off x="6455664" y="3876640"/>
-            <a:ext cx="1280160" cy="631351"/>
+            <a:ext cx="1280160" cy="631352"/>
           </a:xfrm>
           <a:prstGeom prst="rect">
             <a:avLst/>
@@ -5555,7 +5555,7 @@
         <p:spPr>
           <a:xfrm>
             <a:off x="6455664" y="3489682"/>
-            <a:ext cx="1280160" cy="386957"/>
+            <a:ext cx="1280160" cy="386958"/>
           </a:xfrm>
           <a:prstGeom prst="rect">
             <a:avLst/>
@@ -5597,7 +5597,7 @@
         </p:nvSpPr>
         <p:spPr>
           <a:xfrm>
-            <a:off x="6455664" y="3520639"/>
+            <a:off x="6455664" y="3520638"/>
             <a:ext cx="1280160" cy="325044"/>
           </a:xfrm>
           <a:prstGeom prst="rect">
@@ -5676,7 +5676,7 @@
         </p:nvSpPr>
         <p:spPr>
           <a:xfrm>
-            <a:off x="6455664" y="3246103"/>
+            <a:off x="6455664" y="3246102"/>
             <a:ext cx="1280160" cy="222398"/>
           </a:xfrm>
           <a:prstGeom prst="rect">
@@ -5749,7 +5749,7 @@
         <p:spPr>
           <a:xfrm>
             <a:off x="8010144" y="4935681"/>
-            <a:ext cx="1280160" cy="916478"/>
+            <a:ext cx="1280160" cy="916479"/>
           </a:xfrm>
           <a:prstGeom prst="rect">
             <a:avLst/>
@@ -5791,8 +5791,8 @@
         </p:nvSpPr>
         <p:spPr>
           <a:xfrm>
-            <a:off x="8010144" y="5009000"/>
-            <a:ext cx="1280160" cy="769841"/>
+            <a:off x="8010144" y="5008999"/>
+            <a:ext cx="1280160" cy="769842"/>
           </a:xfrm>
           <a:prstGeom prst="rect">
             <a:avLst/>
@@ -5870,7 +5870,7 @@
         </p:nvSpPr>
         <p:spPr>
           <a:xfrm>
-            <a:off x="8010144" y="4504733"/>
+            <a:off x="8010144" y="4504732"/>
             <a:ext cx="1280160" cy="393474"/>
           </a:xfrm>
           <a:prstGeom prst="rect">
@@ -5950,7 +5950,7 @@
         <p:spPr>
           <a:xfrm>
             <a:off x="8010144" y="4111258"/>
-            <a:ext cx="1280160" cy="325044"/>
+            <a:ext cx="1280160" cy="325043"/>
           </a:xfrm>
           <a:prstGeom prst="rect">
             <a:avLst/>
@@ -5986,7 +5986,7 @@
         <p:spPr>
           <a:xfrm>
             <a:off x="8010144" y="3917372"/>
-            <a:ext cx="1280160" cy="162929"/>
+            <a:ext cx="1280160" cy="162930"/>
           </a:xfrm>
           <a:prstGeom prst="rect">
             <a:avLst/>
@@ -6065,7 +6065,7 @@
         <p:spPr>
           <a:xfrm>
             <a:off x="9564624" y="5424470"/>
-            <a:ext cx="1280160" cy="427689"/>
+            <a:ext cx="1280160" cy="427690"/>
           </a:xfrm>
           <a:prstGeom prst="rect">
             <a:avLst/>
@@ -6144,7 +6144,7 @@
         <p:spPr>
           <a:xfrm>
             <a:off x="9564624" y="5261540"/>
-            <a:ext cx="1280160" cy="162929"/>
+            <a:ext cx="1280160" cy="162930"/>
           </a:xfrm>
           <a:prstGeom prst="rect">
             <a:avLst/>
@@ -6187,7 +6187,7 @@
         <p:spPr>
           <a:xfrm>
             <a:off x="9564624" y="5159709"/>
-            <a:ext cx="1280160" cy="101830"/>
+            <a:ext cx="1280160" cy="101831"/>
           </a:xfrm>
           <a:prstGeom prst="rect">
             <a:avLst/>
@@ -6266,7 +6266,7 @@
         <p:spPr>
           <a:xfrm>
             <a:off x="3383280" y="1921486"/>
-            <a:ext cx="822960" cy="427689"/>
+            <a:ext cx="822960" cy="427690"/>
           </a:xfrm>
           <a:prstGeom prst="rect">
             <a:avLst/>
@@ -6308,7 +6308,7 @@
         </p:nvSpPr>
         <p:spPr>
           <a:xfrm>
-            <a:off x="3383280" y="1955702"/>
+            <a:off x="3383280" y="1955701"/>
             <a:ext cx="822960" cy="359259"/>
           </a:xfrm>
           <a:prstGeom prst="rect">
@@ -6345,7 +6345,7 @@
         <p:spPr>
           <a:xfrm>
             <a:off x="4370832" y="2349176"/>
-            <a:ext cx="822960" cy="427689"/>
+            <a:ext cx="822960" cy="427690"/>
           </a:xfrm>
           <a:prstGeom prst="rect">
             <a:avLst/>
@@ -6466,7 +6466,7 @@
         </p:nvSpPr>
         <p:spPr>
           <a:xfrm>
-            <a:off x="5358384" y="2812711"/>
+            <a:off x="5358384" y="2812710"/>
             <a:ext cx="822960" cy="376367"/>
           </a:xfrm>
           <a:prstGeom prst="rect">
@@ -6817,7 +6817,7 @@
         </p:nvSpPr>
         <p:spPr>
           <a:xfrm>
-            <a:off x="457200" y="4744696"/>
+            <a:off x="457200" y="4754880"/>
             <a:ext cx="1325880" cy="402336"/>
           </a:xfrm>
           <a:prstGeom prst="rect">
@@ -6853,7 +6853,7 @@
         </p:nvSpPr>
         <p:spPr>
           <a:xfrm>
-            <a:off x="457200" y="3380162"/>
+            <a:off x="457200" y="3390345"/>
             <a:ext cx="1325880" cy="402336"/>
           </a:xfrm>
           <a:prstGeom prst="rect">
@@ -6925,7 +6925,7 @@
         </p:nvSpPr>
         <p:spPr>
           <a:xfrm>
-            <a:off x="457200" y="1974896"/>
+            <a:off x="457200" y="1985079"/>
             <a:ext cx="1325880" cy="402336"/>
           </a:xfrm>
           <a:prstGeom prst="rect">
@@ -6961,8 +6961,8 @@
         </p:nvCxnSpPr>
         <p:spPr>
           <a:xfrm>
-            <a:off x="3108960" y="1921486.909090909"/>
-            <a:ext cx="274320" cy="0.0"/>
+            <a:off x="3108960" y="1921486"/>
+            <a:ext cx="274320" cy="0"/>
           </a:xfrm>
           <a:prstGeom prst="line">
             <a:avLst/>
@@ -6997,8 +6997,8 @@
         </p:nvCxnSpPr>
         <p:spPr>
           <a:xfrm>
-            <a:off x="4206240" y="2349176.727272727"/>
-            <a:ext cx="164592" cy="0.0"/>
+            <a:off x="4206240" y="2349176"/>
+            <a:ext cx="164592" cy="0"/>
           </a:xfrm>
           <a:prstGeom prst="line">
             <a:avLst/>
@@ -7033,8 +7033,8 @@
         </p:nvCxnSpPr>
         <p:spPr>
           <a:xfrm>
-            <a:off x="5193792" y="2776866.5454545454"/>
-            <a:ext cx="164592" cy="0.0"/>
+            <a:off x="5193792" y="2776866"/>
+            <a:ext cx="164592" cy="0"/>
           </a:xfrm>
           <a:prstGeom prst="line">
             <a:avLst/>
@@ -7069,8 +7069,8 @@
         </p:nvCxnSpPr>
         <p:spPr>
           <a:xfrm>
-            <a:off x="6181344" y="3224922.545454546"/>
-            <a:ext cx="274320" cy="0.0"/>
+            <a:off x="6181344" y="3224922"/>
+            <a:ext cx="274320" cy="0"/>
           </a:xfrm>
           <a:prstGeom prst="line">
             <a:avLst/>
@@ -7105,8 +7105,8 @@
         </p:nvCxnSpPr>
         <p:spPr>
           <a:xfrm>
-            <a:off x="7735824" y="3917372.727272727"/>
-            <a:ext cx="274320" cy="0.0"/>
+            <a:off x="7735824" y="3917372"/>
+            <a:ext cx="274320" cy="0"/>
           </a:xfrm>
           <a:prstGeom prst="line">
             <a:avLst/>
@@ -7141,8 +7141,8 @@
         </p:nvCxnSpPr>
         <p:spPr>
           <a:xfrm>
-            <a:off x="9290304" y="5159709.818181818"/>
-            <a:ext cx="274320" cy="0.0"/>
+            <a:off x="9290304" y="5159709"/>
+            <a:ext cx="274320" cy="0"/>
           </a:xfrm>
           <a:prstGeom prst="line">
             <a:avLst/>

</xml_diff>